<commit_message>
Make the character a small corner mascot on five pages
Instead of a large figure on the cover, the character is now a small
(180px) waving mascot in the bottom-right corner of the cover, the
練習問題 intro page and the three 解答 pages. The cover goes back to
title left + contents list right, with the list moved up to clear the
mascot.

Co-Authored-By: Claude Opus 5.5 <noreply@anthropic.com>
Claude-Session: https://claude.ai/code/session_01MF7F8qN3KDcVRZ6BHTvofb
</commit_message>
<xml_diff>
--- a/matome/9-phrases/9-phrases-matome.pptx
+++ b/matome/9-phrases/9-phrases-matome.pptx
@@ -519,8 +519,8 @@
         </p:blipFill>
         <p:spPr>
           <a:xfrm>
-            <a:off x="7820025" y="1524000"/>
-            <a:ext cx="3990975" cy="5334000"/>
+            <a:off x="10563225" y="5143500"/>
+            <a:ext cx="1285875" cy="1714500"/>
           </a:xfrm>
           <a:prstGeom prst="rect">
             <a:avLst/>
@@ -535,7 +535,7 @@
         </p:nvSpPr>
         <p:spPr>
           <a:xfrm>
-            <a:off x="838200" y="695325"/>
+            <a:off x="838200" y="1571625"/>
             <a:ext cx="2000250" cy="276225"/>
           </a:xfrm>
           <a:prstGeom prst="rect">
@@ -570,22 +570,22 @@
         </p:nvSpPr>
         <p:spPr>
           <a:xfrm>
-            <a:off x="838200" y="1019175"/>
-            <a:ext cx="6619875" cy="876300"/>
-          </a:xfrm>
-          <a:prstGeom prst="rect">
-            <a:avLst/>
-          </a:prstGeom>
-          <a:noFill/>
-          <a:ln/>
-        </p:spPr>
-        <p:txBody>
-          <a:bodyPr wrap="square" lIns="0" tIns="0" rIns="0" bIns="0" anchor="ctr"/>
-          <a:lstStyle/>
-          <a:p>
-            <a:pPr/>
-            <a:r>
-              <a:rPr sz="4800" b="1">
+            <a:off x="838200" y="1952625"/>
+            <a:ext cx="7010400" cy="942975"/>
+          </a:xfrm>
+          <a:prstGeom prst="rect">
+            <a:avLst/>
+          </a:prstGeom>
+          <a:noFill/>
+          <a:ln/>
+        </p:spPr>
+        <p:txBody>
+          <a:bodyPr wrap="square" lIns="0" tIns="0" rIns="0" bIns="0" anchor="ctr"/>
+          <a:lstStyle/>
+          <a:p>
+            <a:pPr/>
+            <a:r>
+              <a:rPr sz="5100" b="1">
                 <a:solidFill>
                   <a:srgbClr val="1E1A1C"/>
                 </a:solidFill>
@@ -605,22 +605,22 @@
         </p:nvSpPr>
         <p:spPr>
           <a:xfrm>
-            <a:off x="838200" y="1771650"/>
-            <a:ext cx="1685925" cy="1190625"/>
-          </a:xfrm>
-          <a:prstGeom prst="rect">
-            <a:avLst/>
-          </a:prstGeom>
-          <a:noFill/>
-          <a:ln/>
-        </p:spPr>
-        <p:txBody>
-          <a:bodyPr wrap="square" lIns="0" tIns="0" rIns="0" bIns="0" anchor="ctr"/>
-          <a:lstStyle/>
-          <a:p>
-            <a:pPr/>
-            <a:r>
-              <a:rPr sz="8400" b="1">
+            <a:off x="838200" y="2762250"/>
+            <a:ext cx="1790700" cy="1276350"/>
+          </a:xfrm>
+          <a:prstGeom prst="rect">
+            <a:avLst/>
+          </a:prstGeom>
+          <a:noFill/>
+          <a:ln/>
+        </p:spPr>
+        <p:txBody>
+          <a:bodyPr wrap="square" lIns="0" tIns="0" rIns="0" bIns="0" anchor="ctr"/>
+          <a:lstStyle/>
+          <a:p>
+            <a:pPr/>
+            <a:r>
+              <a:rPr sz="9000" b="1">
                 <a:solidFill>
                   <a:srgbClr val="1E1A1C"/>
                 </a:solidFill>
@@ -631,7 +631,7 @@
             </a:r>
             <a:pPr/>
             <a:r>
-              <a:rPr sz="4800" b="1">
+              <a:rPr sz="5100" b="1">
                 <a:solidFill>
                   <a:srgbClr val="1E1A1C"/>
                 </a:solidFill>
@@ -651,22 +651,22 @@
         </p:nvSpPr>
         <p:spPr>
           <a:xfrm>
-            <a:off x="2162175" y="2028825"/>
-            <a:ext cx="2447925" cy="876300"/>
-          </a:xfrm>
-          <a:prstGeom prst="rect">
-            <a:avLst/>
-          </a:prstGeom>
-          <a:noFill/>
-          <a:ln/>
-        </p:spPr>
-        <p:txBody>
-          <a:bodyPr wrap="square" lIns="0" tIns="0" rIns="0" bIns="0" anchor="ctr"/>
-          <a:lstStyle/>
-          <a:p>
-            <a:pPr/>
-            <a:r>
-              <a:rPr sz="4800" b="1">
+            <a:off x="2247900" y="3048000"/>
+            <a:ext cx="2581275" cy="942975"/>
+          </a:xfrm>
+          <a:prstGeom prst="rect">
+            <a:avLst/>
+          </a:prstGeom>
+          <a:noFill/>
+          <a:ln/>
+        </p:spPr>
+        <p:txBody>
+          <a:bodyPr wrap="square" lIns="0" tIns="0" rIns="0" bIns="0" anchor="ctr"/>
+          <a:lstStyle/>
+          <a:p>
+            <a:pPr/>
+            <a:r>
+              <a:rPr sz="5100" b="1">
                 <a:solidFill>
                   <a:srgbClr val="1E1A1C"/>
                 </a:solidFill>
@@ -689,7 +689,7 @@
         </p:nvSpPr>
         <p:spPr>
           <a:xfrm>
-            <a:off x="838200" y="3133725"/>
+            <a:off x="838200" y="4257675"/>
             <a:ext cx="3429000" cy="57150"/>
           </a:xfrm>
           <a:prstGeom prst="roundRect">
@@ -711,22 +711,22 @@
         </p:nvSpPr>
         <p:spPr>
           <a:xfrm>
-            <a:off x="838200" y="3419475"/>
-            <a:ext cx="3619500" cy="276225"/>
-          </a:xfrm>
-          <a:prstGeom prst="rect">
-            <a:avLst/>
-          </a:prstGeom>
-          <a:noFill/>
-          <a:ln/>
-        </p:spPr>
-        <p:txBody>
-          <a:bodyPr wrap="square" lIns="0" tIns="0" rIns="0" bIns="0" anchor="ctr"/>
-          <a:lstStyle/>
-          <a:p>
-            <a:pPr/>
-            <a:r>
-              <a:rPr sz="1500" b="1">
+            <a:off x="838200" y="4610100"/>
+            <a:ext cx="3781425" cy="285750"/>
+          </a:xfrm>
+          <a:prstGeom prst="rect">
+            <a:avLst/>
+          </a:prstGeom>
+          <a:noFill/>
+          <a:ln/>
+        </p:spPr>
+        <p:txBody>
+          <a:bodyPr wrap="square" lIns="0" tIns="0" rIns="0" bIns="0" anchor="ctr"/>
+          <a:lstStyle/>
+          <a:p>
+            <a:pPr/>
+            <a:r>
+              <a:rPr sz="1600" b="1">
                 <a:solidFill>
                   <a:srgbClr val="574D52"/>
                 </a:solidFill>
@@ -746,22 +746,22 @@
         </p:nvSpPr>
         <p:spPr>
           <a:xfrm>
-            <a:off x="838200" y="3743325"/>
-            <a:ext cx="4067175" cy="276225"/>
-          </a:xfrm>
-          <a:prstGeom prst="rect">
-            <a:avLst/>
-          </a:prstGeom>
-          <a:noFill/>
-          <a:ln/>
-        </p:spPr>
-        <p:txBody>
-          <a:bodyPr wrap="square" lIns="0" tIns="0" rIns="0" bIns="0" anchor="ctr"/>
-          <a:lstStyle/>
-          <a:p>
-            <a:pPr/>
-            <a:r>
-              <a:rPr sz="1500" b="1">
+            <a:off x="838200" y="4962525"/>
+            <a:ext cx="4257675" cy="285750"/>
+          </a:xfrm>
+          <a:prstGeom prst="rect">
+            <a:avLst/>
+          </a:prstGeom>
+          <a:noFill/>
+          <a:ln/>
+        </p:spPr>
+        <p:txBody>
+          <a:bodyPr wrap="square" lIns="0" tIns="0" rIns="0" bIns="0" anchor="ctr"/>
+          <a:lstStyle/>
+          <a:p>
+            <a:pPr/>
+            <a:r>
+              <a:rPr sz="1600" b="1">
                 <a:solidFill>
                   <a:srgbClr val="574D52"/>
                 </a:solidFill>
@@ -781,22 +781,22 @@
         </p:nvSpPr>
         <p:spPr>
           <a:xfrm>
-            <a:off x="838200" y="4333875"/>
-            <a:ext cx="1428750" cy="152400"/>
-          </a:xfrm>
-          <a:prstGeom prst="rect">
-            <a:avLst/>
-          </a:prstGeom>
-          <a:noFill/>
-          <a:ln/>
-        </p:spPr>
-        <p:txBody>
-          <a:bodyPr wrap="square" lIns="0" tIns="0" rIns="0" bIns="0" anchor="ctr"/>
-          <a:lstStyle/>
-          <a:p>
-            <a:pPr/>
-            <a:r>
-              <a:rPr sz="1050" b="1">
+            <a:off x="7715250" y="552450"/>
+            <a:ext cx="1514475" cy="161925"/>
+          </a:xfrm>
+          <a:prstGeom prst="rect">
+            <a:avLst/>
+          </a:prstGeom>
+          <a:noFill/>
+          <a:ln/>
+        </p:spPr>
+        <p:txBody>
+          <a:bodyPr wrap="square" lIns="0" tIns="0" rIns="0" bIns="0" anchor="ctr"/>
+          <a:lstStyle/>
+          <a:p>
+            <a:pPr/>
+            <a:r>
+              <a:rPr sz="1150" b="1">
                 <a:solidFill>
                   <a:srgbClr val="9C9196"/>
                 </a:solidFill>
@@ -811,22 +811,88 @@
       <p:sp>
         <p:nvSpPr>
           <p:cNvPr id="12" name=""/>
+          <p:cNvSpPr txBox="1"/>
+          <p:nvPr/>
+        </p:nvSpPr>
+        <p:spPr>
+          <a:xfrm>
+            <a:off x="8058150" y="876300"/>
+            <a:ext cx="1885950" cy="219075"/>
+          </a:xfrm>
+          <a:prstGeom prst="rect">
+            <a:avLst/>
+          </a:prstGeom>
+          <a:noFill/>
+          <a:ln/>
+        </p:spPr>
+        <p:txBody>
+          <a:bodyPr wrap="square" lIns="0" tIns="0" rIns="0" bIns="0" anchor="ctr"/>
+          <a:lstStyle/>
+          <a:p>
+            <a:pPr/>
+            <a:r>
+              <a:rPr sz="1600" b="1">
+                <a:solidFill>
+                  <a:srgbClr val="1E1A1C"/>
+                </a:solidFill>
+                <a:latin typeface="Arial"/>
+                <a:ea typeface="Arial"/>
+              </a:rPr>
+              <a:t>I feel like ~ing</a:t>
+            </a:r>
+          </a:p>
+        </p:txBody>
+      </p:sp>
+      <p:sp>
+        <p:nvSpPr>
+          <p:cNvPr id="13" name=""/>
+          <p:cNvSpPr txBox="1"/>
+          <p:nvPr/>
+        </p:nvSpPr>
+        <p:spPr>
+          <a:xfrm>
+            <a:off x="7715250" y="876300"/>
+            <a:ext cx="476250" cy="219075"/>
+          </a:xfrm>
+          <a:prstGeom prst="rect">
+            <a:avLst/>
+          </a:prstGeom>
+          <a:noFill/>
+          <a:ln/>
+        </p:spPr>
+        <p:txBody>
+          <a:bodyPr wrap="square" lIns="0" tIns="0" rIns="0" bIns="0" anchor="ctr"/>
+          <a:lstStyle/>
+          <a:p>
+            <a:pPr/>
+            <a:r>
+              <a:rPr sz="1600" b="1">
+                <a:solidFill>
+                  <a:srgbClr val="C8417F"/>
+                </a:solidFill>
+                <a:latin typeface="Arial"/>
+                <a:ea typeface="Arial"/>
+              </a:rPr>
+              <a:t>1</a:t>
+            </a:r>
+          </a:p>
+        </p:txBody>
+      </p:sp>
+      <p:sp>
+        <p:nvSpPr>
+          <p:cNvPr id="14" name=""/>
           <p:cNvSpPr/>
           <p:nvPr/>
         </p:nvSpPr>
         <p:spPr>
           <a:xfrm>
-            <a:off x="838200" y="4581525"/>
-            <a:ext cx="2200275" cy="361950"/>
-          </a:xfrm>
-          <a:prstGeom prst="roundRect">
-            <a:avLst>
-              <a:gd name="adj" fmla="val 26316"/>
-            </a:avLst>
-          </a:prstGeom>
-          <a:solidFill>
-            <a:srgbClr val="FFFFFF"/>
-          </a:solidFill>
+            <a:off x="7715250" y="1200150"/>
+            <a:ext cx="3638550" cy="0"/>
+          </a:xfrm>
+          <a:prstGeom prst="line">
+            <a:avLst/>
+          </a:prstGeom>
+          <a:noFill/>
           <a:ln w="19050">
             <a:solidFill>
               <a:srgbClr val="F2D5E1"/>
@@ -837,93 +903,89 @@
       </p:sp>
       <p:sp>
         <p:nvSpPr>
-          <p:cNvPr id="13" name=""/>
-          <p:cNvSpPr txBox="1"/>
-          <p:nvPr/>
-        </p:nvSpPr>
-        <p:spPr>
-          <a:xfrm>
-            <a:off x="1152525" y="4676775"/>
-            <a:ext cx="1457325" cy="161925"/>
-          </a:xfrm>
-          <a:prstGeom prst="rect">
-            <a:avLst/>
-          </a:prstGeom>
-          <a:noFill/>
-          <a:ln/>
-        </p:spPr>
-        <p:txBody>
-          <a:bodyPr wrap="square" lIns="0" tIns="0" rIns="0" bIns="0" anchor="ctr"/>
-          <a:lstStyle/>
-          <a:p>
-            <a:pPr/>
-            <a:r>
-              <a:rPr sz="1200" b="1">
-                <a:solidFill>
-                  <a:srgbClr val="1E1A1C"/>
-                </a:solidFill>
-                <a:latin typeface="Arial"/>
-                <a:ea typeface="Arial"/>
-              </a:rPr>
-              <a:t>I feel like ~ing</a:t>
-            </a:r>
-          </a:p>
-        </p:txBody>
-      </p:sp>
-      <p:sp>
-        <p:nvSpPr>
-          <p:cNvPr id="14" name=""/>
-          <p:cNvSpPr txBox="1"/>
-          <p:nvPr/>
-        </p:nvSpPr>
-        <p:spPr>
-          <a:xfrm>
-            <a:off x="971550" y="4676775"/>
-            <a:ext cx="438150" cy="161925"/>
-          </a:xfrm>
-          <a:prstGeom prst="rect">
-            <a:avLst/>
-          </a:prstGeom>
-          <a:noFill/>
-          <a:ln/>
-        </p:spPr>
-        <p:txBody>
-          <a:bodyPr wrap="square" lIns="0" tIns="0" rIns="0" bIns="0" anchor="ctr"/>
-          <a:lstStyle/>
-          <a:p>
-            <a:pPr/>
-            <a:r>
-              <a:rPr sz="1200" b="1">
+          <p:cNvPr id="15" name=""/>
+          <p:cNvSpPr txBox="1"/>
+          <p:nvPr/>
+        </p:nvSpPr>
+        <p:spPr>
+          <a:xfrm>
+            <a:off x="8058150" y="1295400"/>
+            <a:ext cx="1504950" cy="219075"/>
+          </a:xfrm>
+          <a:prstGeom prst="rect">
+            <a:avLst/>
+          </a:prstGeom>
+          <a:noFill/>
+          <a:ln/>
+        </p:spPr>
+        <p:txBody>
+          <a:bodyPr wrap="square" lIns="0" tIns="0" rIns="0" bIns="0" anchor="ctr"/>
+          <a:lstStyle/>
+          <a:p>
+            <a:pPr/>
+            <a:r>
+              <a:rPr sz="1600" b="1">
+                <a:solidFill>
+                  <a:srgbClr val="1E1A1C"/>
+                </a:solidFill>
+                <a:latin typeface="Arial"/>
+                <a:ea typeface="Arial"/>
+              </a:rPr>
+              <a:t>I used to ~</a:t>
+            </a:r>
+          </a:p>
+        </p:txBody>
+      </p:sp>
+      <p:sp>
+        <p:nvSpPr>
+          <p:cNvPr id="16" name=""/>
+          <p:cNvSpPr txBox="1"/>
+          <p:nvPr/>
+        </p:nvSpPr>
+        <p:spPr>
+          <a:xfrm>
+            <a:off x="7715250" y="1295400"/>
+            <a:ext cx="476250" cy="219075"/>
+          </a:xfrm>
+          <a:prstGeom prst="rect">
+            <a:avLst/>
+          </a:prstGeom>
+          <a:noFill/>
+          <a:ln/>
+        </p:spPr>
+        <p:txBody>
+          <a:bodyPr wrap="square" lIns="0" tIns="0" rIns="0" bIns="0" anchor="ctr"/>
+          <a:lstStyle/>
+          <a:p>
+            <a:pPr/>
+            <a:r>
+              <a:rPr sz="1600" b="1">
                 <a:solidFill>
                   <a:srgbClr val="C8417F"/>
                 </a:solidFill>
                 <a:latin typeface="Arial"/>
                 <a:ea typeface="Arial"/>
               </a:rPr>
-              <a:t>1</a:t>
-            </a:r>
-          </a:p>
-        </p:txBody>
-      </p:sp>
-      <p:sp>
-        <p:nvSpPr>
-          <p:cNvPr id="15" name=""/>
+              <a:t>2</a:t>
+            </a:r>
+          </a:p>
+        </p:txBody>
+      </p:sp>
+      <p:sp>
+        <p:nvSpPr>
+          <p:cNvPr id="17" name=""/>
           <p:cNvSpPr/>
           <p:nvPr/>
         </p:nvSpPr>
         <p:spPr>
           <a:xfrm>
-            <a:off x="3133725" y="4581525"/>
-            <a:ext cx="2200275" cy="361950"/>
-          </a:xfrm>
-          <a:prstGeom prst="roundRect">
-            <a:avLst>
-              <a:gd name="adj" fmla="val 26316"/>
-            </a:avLst>
-          </a:prstGeom>
-          <a:solidFill>
-            <a:srgbClr val="FFFFFF"/>
-          </a:solidFill>
+            <a:off x="7715250" y="1619250"/>
+            <a:ext cx="3638550" cy="0"/>
+          </a:xfrm>
+          <a:prstGeom prst="line">
+            <a:avLst/>
+          </a:prstGeom>
+          <a:noFill/>
           <a:ln w="19050">
             <a:solidFill>
               <a:srgbClr val="F2D5E1"/>
@@ -934,93 +996,89 @@
       </p:sp>
       <p:sp>
         <p:nvSpPr>
-          <p:cNvPr id="16" name=""/>
-          <p:cNvSpPr txBox="1"/>
-          <p:nvPr/>
-        </p:nvSpPr>
-        <p:spPr>
-          <a:xfrm>
-            <a:off x="3448050" y="4676775"/>
-            <a:ext cx="1200150" cy="161925"/>
-          </a:xfrm>
-          <a:prstGeom prst="rect">
-            <a:avLst/>
-          </a:prstGeom>
-          <a:noFill/>
-          <a:ln/>
-        </p:spPr>
-        <p:txBody>
-          <a:bodyPr wrap="square" lIns="0" tIns="0" rIns="0" bIns="0" anchor="ctr"/>
-          <a:lstStyle/>
-          <a:p>
-            <a:pPr/>
-            <a:r>
-              <a:rPr sz="1200" b="1">
-                <a:solidFill>
-                  <a:srgbClr val="1E1A1C"/>
-                </a:solidFill>
-                <a:latin typeface="Arial"/>
-                <a:ea typeface="Arial"/>
-              </a:rPr>
-              <a:t>I used to ~</a:t>
-            </a:r>
-          </a:p>
-        </p:txBody>
-      </p:sp>
-      <p:sp>
-        <p:nvSpPr>
-          <p:cNvPr id="17" name=""/>
-          <p:cNvSpPr txBox="1"/>
-          <p:nvPr/>
-        </p:nvSpPr>
-        <p:spPr>
-          <a:xfrm>
-            <a:off x="3267075" y="4676775"/>
-            <a:ext cx="438150" cy="161925"/>
-          </a:xfrm>
-          <a:prstGeom prst="rect">
-            <a:avLst/>
-          </a:prstGeom>
-          <a:noFill/>
-          <a:ln/>
-        </p:spPr>
-        <p:txBody>
-          <a:bodyPr wrap="square" lIns="0" tIns="0" rIns="0" bIns="0" anchor="ctr"/>
-          <a:lstStyle/>
-          <a:p>
-            <a:pPr/>
-            <a:r>
-              <a:rPr sz="1200" b="1">
+          <p:cNvPr id="18" name=""/>
+          <p:cNvSpPr txBox="1"/>
+          <p:nvPr/>
+        </p:nvSpPr>
+        <p:spPr>
+          <a:xfrm>
+            <a:off x="8058150" y="1714500"/>
+            <a:ext cx="2038350" cy="219075"/>
+          </a:xfrm>
+          <a:prstGeom prst="rect">
+            <a:avLst/>
+          </a:prstGeom>
+          <a:noFill/>
+          <a:ln/>
+        </p:spPr>
+        <p:txBody>
+          <a:bodyPr wrap="square" lIns="0" tIns="0" rIns="0" bIns="0" anchor="ctr"/>
+          <a:lstStyle/>
+          <a:p>
+            <a:pPr/>
+            <a:r>
+              <a:rPr sz="1600" b="1">
+                <a:solidFill>
+                  <a:srgbClr val="1E1A1C"/>
+                </a:solidFill>
+                <a:latin typeface="Arial"/>
+                <a:ea typeface="Arial"/>
+              </a:rPr>
+              <a:t>I should have ~</a:t>
+            </a:r>
+          </a:p>
+        </p:txBody>
+      </p:sp>
+      <p:sp>
+        <p:nvSpPr>
+          <p:cNvPr id="19" name=""/>
+          <p:cNvSpPr txBox="1"/>
+          <p:nvPr/>
+        </p:nvSpPr>
+        <p:spPr>
+          <a:xfrm>
+            <a:off x="7715250" y="1714500"/>
+            <a:ext cx="476250" cy="219075"/>
+          </a:xfrm>
+          <a:prstGeom prst="rect">
+            <a:avLst/>
+          </a:prstGeom>
+          <a:noFill/>
+          <a:ln/>
+        </p:spPr>
+        <p:txBody>
+          <a:bodyPr wrap="square" lIns="0" tIns="0" rIns="0" bIns="0" anchor="ctr"/>
+          <a:lstStyle/>
+          <a:p>
+            <a:pPr/>
+            <a:r>
+              <a:rPr sz="1600" b="1">
                 <a:solidFill>
                   <a:srgbClr val="C8417F"/>
                 </a:solidFill>
                 <a:latin typeface="Arial"/>
                 <a:ea typeface="Arial"/>
               </a:rPr>
-              <a:t>2</a:t>
-            </a:r>
-          </a:p>
-        </p:txBody>
-      </p:sp>
-      <p:sp>
-        <p:nvSpPr>
-          <p:cNvPr id="18" name=""/>
+              <a:t>3</a:t>
+            </a:r>
+          </a:p>
+        </p:txBody>
+      </p:sp>
+      <p:sp>
+        <p:nvSpPr>
+          <p:cNvPr id="20" name=""/>
           <p:cNvSpPr/>
           <p:nvPr/>
         </p:nvSpPr>
         <p:spPr>
           <a:xfrm>
-            <a:off x="5419725" y="4581525"/>
-            <a:ext cx="2200275" cy="361950"/>
-          </a:xfrm>
-          <a:prstGeom prst="roundRect">
-            <a:avLst>
-              <a:gd name="adj" fmla="val 26316"/>
-            </a:avLst>
-          </a:prstGeom>
-          <a:solidFill>
-            <a:srgbClr val="FFFFFF"/>
-          </a:solidFill>
+            <a:off x="7715250" y="2038350"/>
+            <a:ext cx="3638550" cy="0"/>
+          </a:xfrm>
+          <a:prstGeom prst="line">
+            <a:avLst/>
+          </a:prstGeom>
+          <a:noFill/>
           <a:ln w="19050">
             <a:solidFill>
               <a:srgbClr val="F2D5E1"/>
@@ -1031,93 +1089,89 @@
       </p:sp>
       <p:sp>
         <p:nvSpPr>
-          <p:cNvPr id="19" name=""/>
-          <p:cNvSpPr txBox="1"/>
-          <p:nvPr/>
-        </p:nvSpPr>
-        <p:spPr>
-          <a:xfrm>
-            <a:off x="5734050" y="4676775"/>
-            <a:ext cx="1600200" cy="161925"/>
-          </a:xfrm>
-          <a:prstGeom prst="rect">
-            <a:avLst/>
-          </a:prstGeom>
-          <a:noFill/>
-          <a:ln/>
-        </p:spPr>
-        <p:txBody>
-          <a:bodyPr wrap="square" lIns="0" tIns="0" rIns="0" bIns="0" anchor="ctr"/>
-          <a:lstStyle/>
-          <a:p>
-            <a:pPr/>
-            <a:r>
-              <a:rPr sz="1200" b="1">
-                <a:solidFill>
-                  <a:srgbClr val="1E1A1C"/>
-                </a:solidFill>
-                <a:latin typeface="Arial"/>
-                <a:ea typeface="Arial"/>
-              </a:rPr>
-              <a:t>I should have ~</a:t>
-            </a:r>
-          </a:p>
-        </p:txBody>
-      </p:sp>
-      <p:sp>
-        <p:nvSpPr>
-          <p:cNvPr id="20" name=""/>
-          <p:cNvSpPr txBox="1"/>
-          <p:nvPr/>
-        </p:nvSpPr>
-        <p:spPr>
-          <a:xfrm>
-            <a:off x="5553075" y="4676775"/>
-            <a:ext cx="438150" cy="161925"/>
-          </a:xfrm>
-          <a:prstGeom prst="rect">
-            <a:avLst/>
-          </a:prstGeom>
-          <a:noFill/>
-          <a:ln/>
-        </p:spPr>
-        <p:txBody>
-          <a:bodyPr wrap="square" lIns="0" tIns="0" rIns="0" bIns="0" anchor="ctr"/>
-          <a:lstStyle/>
-          <a:p>
-            <a:pPr/>
-            <a:r>
-              <a:rPr sz="1200" b="1">
+          <p:cNvPr id="21" name=""/>
+          <p:cNvSpPr txBox="1"/>
+          <p:nvPr/>
+        </p:nvSpPr>
+        <p:spPr>
+          <a:xfrm>
+            <a:off x="8058150" y="2133600"/>
+            <a:ext cx="2257425" cy="219075"/>
+          </a:xfrm>
+          <a:prstGeom prst="rect">
+            <a:avLst/>
+          </a:prstGeom>
+          <a:noFill/>
+          <a:ln/>
+        </p:spPr>
+        <p:txBody>
+          <a:bodyPr wrap="square" lIns="0" tIns="0" rIns="0" bIns="0" anchor="ctr"/>
+          <a:lstStyle/>
+          <a:p>
+            <a:pPr/>
+            <a:r>
+              <a:rPr sz="1600" b="1">
+                <a:solidFill>
+                  <a:srgbClr val="1E1A1C"/>
+                </a:solidFill>
+                <a:latin typeface="Arial"/>
+                <a:ea typeface="Arial"/>
+              </a:rPr>
+              <a:t>Do you wanna ~?</a:t>
+            </a:r>
+          </a:p>
+        </p:txBody>
+      </p:sp>
+      <p:sp>
+        <p:nvSpPr>
+          <p:cNvPr id="22" name=""/>
+          <p:cNvSpPr txBox="1"/>
+          <p:nvPr/>
+        </p:nvSpPr>
+        <p:spPr>
+          <a:xfrm>
+            <a:off x="7715250" y="2133600"/>
+            <a:ext cx="476250" cy="219075"/>
+          </a:xfrm>
+          <a:prstGeom prst="rect">
+            <a:avLst/>
+          </a:prstGeom>
+          <a:noFill/>
+          <a:ln/>
+        </p:spPr>
+        <p:txBody>
+          <a:bodyPr wrap="square" lIns="0" tIns="0" rIns="0" bIns="0" anchor="ctr"/>
+          <a:lstStyle/>
+          <a:p>
+            <a:pPr/>
+            <a:r>
+              <a:rPr sz="1600" b="1">
                 <a:solidFill>
                   <a:srgbClr val="C8417F"/>
                 </a:solidFill>
                 <a:latin typeface="Arial"/>
                 <a:ea typeface="Arial"/>
               </a:rPr>
-              <a:t>3</a:t>
-            </a:r>
-          </a:p>
-        </p:txBody>
-      </p:sp>
-      <p:sp>
-        <p:nvSpPr>
-          <p:cNvPr id="21" name=""/>
+              <a:t>4</a:t>
+            </a:r>
+          </a:p>
+        </p:txBody>
+      </p:sp>
+      <p:sp>
+        <p:nvSpPr>
+          <p:cNvPr id="23" name=""/>
           <p:cNvSpPr/>
           <p:nvPr/>
         </p:nvSpPr>
         <p:spPr>
           <a:xfrm>
-            <a:off x="838200" y="5019675"/>
-            <a:ext cx="2200275" cy="361950"/>
-          </a:xfrm>
-          <a:prstGeom prst="roundRect">
-            <a:avLst>
-              <a:gd name="adj" fmla="val 26316"/>
-            </a:avLst>
-          </a:prstGeom>
-          <a:solidFill>
-            <a:srgbClr val="FFFFFF"/>
-          </a:solidFill>
+            <a:off x="7715250" y="2457450"/>
+            <a:ext cx="3638550" cy="0"/>
+          </a:xfrm>
+          <a:prstGeom prst="line">
+            <a:avLst/>
+          </a:prstGeom>
+          <a:noFill/>
           <a:ln w="19050">
             <a:solidFill>
               <a:srgbClr val="F2D5E1"/>
@@ -1128,93 +1182,89 @@
       </p:sp>
       <p:sp>
         <p:nvSpPr>
-          <p:cNvPr id="22" name=""/>
-          <p:cNvSpPr txBox="1"/>
-          <p:nvPr/>
-        </p:nvSpPr>
-        <p:spPr>
-          <a:xfrm>
-            <a:off x="1152525" y="5114925"/>
-            <a:ext cx="1790700" cy="161925"/>
-          </a:xfrm>
-          <a:prstGeom prst="rect">
-            <a:avLst/>
-          </a:prstGeom>
-          <a:noFill/>
-          <a:ln/>
-        </p:spPr>
-        <p:txBody>
-          <a:bodyPr wrap="square" lIns="0" tIns="0" rIns="0" bIns="0" anchor="ctr"/>
-          <a:lstStyle/>
-          <a:p>
-            <a:pPr/>
-            <a:r>
-              <a:rPr sz="1200" b="1">
-                <a:solidFill>
-                  <a:srgbClr val="1E1A1C"/>
-                </a:solidFill>
-                <a:latin typeface="Arial"/>
-                <a:ea typeface="Arial"/>
-              </a:rPr>
-              <a:t>Do you wanna ~?</a:t>
-            </a:r>
-          </a:p>
-        </p:txBody>
-      </p:sp>
-      <p:sp>
-        <p:nvSpPr>
-          <p:cNvPr id="23" name=""/>
-          <p:cNvSpPr txBox="1"/>
-          <p:nvPr/>
-        </p:nvSpPr>
-        <p:spPr>
-          <a:xfrm>
-            <a:off x="971550" y="5114925"/>
-            <a:ext cx="438150" cy="161925"/>
-          </a:xfrm>
-          <a:prstGeom prst="rect">
-            <a:avLst/>
-          </a:prstGeom>
-          <a:noFill/>
-          <a:ln/>
-        </p:spPr>
-        <p:txBody>
-          <a:bodyPr wrap="square" lIns="0" tIns="0" rIns="0" bIns="0" anchor="ctr"/>
-          <a:lstStyle/>
-          <a:p>
-            <a:pPr/>
-            <a:r>
-              <a:rPr sz="1200" b="1">
+          <p:cNvPr id="24" name=""/>
+          <p:cNvSpPr txBox="1"/>
+          <p:nvPr/>
+        </p:nvSpPr>
+        <p:spPr>
+          <a:xfrm>
+            <a:off x="8058150" y="2552700"/>
+            <a:ext cx="2143125" cy="219075"/>
+          </a:xfrm>
+          <a:prstGeom prst="rect">
+            <a:avLst/>
+          </a:prstGeom>
+          <a:noFill/>
+          <a:ln/>
+        </p:spPr>
+        <p:txBody>
+          <a:bodyPr wrap="square" lIns="0" tIns="0" rIns="0" bIns="0" anchor="ctr"/>
+          <a:lstStyle/>
+          <a:p>
+            <a:pPr/>
+            <a:r>
+              <a:rPr sz="1600" b="1">
+                <a:solidFill>
+                  <a:srgbClr val="1E1A1C"/>
+                </a:solidFill>
+                <a:latin typeface="Arial"/>
+                <a:ea typeface="Arial"/>
+              </a:rPr>
+              <a:t>I'm looking for ~</a:t>
+            </a:r>
+          </a:p>
+        </p:txBody>
+      </p:sp>
+      <p:sp>
+        <p:nvSpPr>
+          <p:cNvPr id="25" name=""/>
+          <p:cNvSpPr txBox="1"/>
+          <p:nvPr/>
+        </p:nvSpPr>
+        <p:spPr>
+          <a:xfrm>
+            <a:off x="7715250" y="2552700"/>
+            <a:ext cx="476250" cy="219075"/>
+          </a:xfrm>
+          <a:prstGeom prst="rect">
+            <a:avLst/>
+          </a:prstGeom>
+          <a:noFill/>
+          <a:ln/>
+        </p:spPr>
+        <p:txBody>
+          <a:bodyPr wrap="square" lIns="0" tIns="0" rIns="0" bIns="0" anchor="ctr"/>
+          <a:lstStyle/>
+          <a:p>
+            <a:pPr/>
+            <a:r>
+              <a:rPr sz="1600" b="1">
                 <a:solidFill>
                   <a:srgbClr val="C8417F"/>
                 </a:solidFill>
                 <a:latin typeface="Arial"/>
                 <a:ea typeface="Arial"/>
               </a:rPr>
-              <a:t>4</a:t>
-            </a:r>
-          </a:p>
-        </p:txBody>
-      </p:sp>
-      <p:sp>
-        <p:nvSpPr>
-          <p:cNvPr id="24" name=""/>
+              <a:t>5</a:t>
+            </a:r>
+          </a:p>
+        </p:txBody>
+      </p:sp>
+      <p:sp>
+        <p:nvSpPr>
+          <p:cNvPr id="26" name=""/>
           <p:cNvSpPr/>
           <p:nvPr/>
         </p:nvSpPr>
         <p:spPr>
           <a:xfrm>
-            <a:off x="3133725" y="5019675"/>
-            <a:ext cx="2200275" cy="361950"/>
-          </a:xfrm>
-          <a:prstGeom prst="roundRect">
-            <a:avLst>
-              <a:gd name="adj" fmla="val 26316"/>
-            </a:avLst>
-          </a:prstGeom>
-          <a:solidFill>
-            <a:srgbClr val="FFFFFF"/>
-          </a:solidFill>
+            <a:off x="7715250" y="2876550"/>
+            <a:ext cx="3638550" cy="0"/>
+          </a:xfrm>
+          <a:prstGeom prst="line">
+            <a:avLst/>
+          </a:prstGeom>
+          <a:noFill/>
           <a:ln w="19050">
             <a:solidFill>
               <a:srgbClr val="F2D5E1"/>
@@ -1225,93 +1275,89 @@
       </p:sp>
       <p:sp>
         <p:nvSpPr>
-          <p:cNvPr id="25" name=""/>
-          <p:cNvSpPr txBox="1"/>
-          <p:nvPr/>
-        </p:nvSpPr>
-        <p:spPr>
-          <a:xfrm>
-            <a:off x="3448050" y="5114925"/>
-            <a:ext cx="1666875" cy="161925"/>
-          </a:xfrm>
-          <a:prstGeom prst="rect">
-            <a:avLst/>
-          </a:prstGeom>
-          <a:noFill/>
-          <a:ln/>
-        </p:spPr>
-        <p:txBody>
-          <a:bodyPr wrap="square" lIns="0" tIns="0" rIns="0" bIns="0" anchor="ctr"/>
-          <a:lstStyle/>
-          <a:p>
-            <a:pPr/>
-            <a:r>
-              <a:rPr sz="1200" b="1">
-                <a:solidFill>
-                  <a:srgbClr val="1E1A1C"/>
-                </a:solidFill>
-                <a:latin typeface="Arial"/>
-                <a:ea typeface="Arial"/>
-              </a:rPr>
-              <a:t>I'm looking for ~</a:t>
-            </a:r>
-          </a:p>
-        </p:txBody>
-      </p:sp>
-      <p:sp>
-        <p:nvSpPr>
-          <p:cNvPr id="26" name=""/>
-          <p:cNvSpPr txBox="1"/>
-          <p:nvPr/>
-        </p:nvSpPr>
-        <p:spPr>
-          <a:xfrm>
-            <a:off x="3267075" y="5114925"/>
-            <a:ext cx="438150" cy="161925"/>
-          </a:xfrm>
-          <a:prstGeom prst="rect">
-            <a:avLst/>
-          </a:prstGeom>
-          <a:noFill/>
-          <a:ln/>
-        </p:spPr>
-        <p:txBody>
-          <a:bodyPr wrap="square" lIns="0" tIns="0" rIns="0" bIns="0" anchor="ctr"/>
-          <a:lstStyle/>
-          <a:p>
-            <a:pPr/>
-            <a:r>
-              <a:rPr sz="1200" b="1">
+          <p:cNvPr id="27" name=""/>
+          <p:cNvSpPr txBox="1"/>
+          <p:nvPr/>
+        </p:nvSpPr>
+        <p:spPr>
+          <a:xfrm>
+            <a:off x="8058150" y="2971800"/>
+            <a:ext cx="1304925" cy="219075"/>
+          </a:xfrm>
+          <a:prstGeom prst="rect">
+            <a:avLst/>
+          </a:prstGeom>
+          <a:noFill/>
+          <a:ln/>
+        </p:spPr>
+        <p:txBody>
+          <a:bodyPr wrap="square" lIns="0" tIns="0" rIns="0" bIns="0" anchor="ctr"/>
+          <a:lstStyle/>
+          <a:p>
+            <a:pPr/>
+            <a:r>
+              <a:rPr sz="1600" b="1">
+                <a:solidFill>
+                  <a:srgbClr val="1E1A1C"/>
+                </a:solidFill>
+                <a:latin typeface="Arial"/>
+                <a:ea typeface="Arial"/>
+              </a:rPr>
+              <a:t>I might ~</a:t>
+            </a:r>
+          </a:p>
+        </p:txBody>
+      </p:sp>
+      <p:sp>
+        <p:nvSpPr>
+          <p:cNvPr id="28" name=""/>
+          <p:cNvSpPr txBox="1"/>
+          <p:nvPr/>
+        </p:nvSpPr>
+        <p:spPr>
+          <a:xfrm>
+            <a:off x="7715250" y="2971800"/>
+            <a:ext cx="476250" cy="219075"/>
+          </a:xfrm>
+          <a:prstGeom prst="rect">
+            <a:avLst/>
+          </a:prstGeom>
+          <a:noFill/>
+          <a:ln/>
+        </p:spPr>
+        <p:txBody>
+          <a:bodyPr wrap="square" lIns="0" tIns="0" rIns="0" bIns="0" anchor="ctr"/>
+          <a:lstStyle/>
+          <a:p>
+            <a:pPr/>
+            <a:r>
+              <a:rPr sz="1600" b="1">
                 <a:solidFill>
                   <a:srgbClr val="C8417F"/>
                 </a:solidFill>
                 <a:latin typeface="Arial"/>
                 <a:ea typeface="Arial"/>
               </a:rPr>
-              <a:t>5</a:t>
-            </a:r>
-          </a:p>
-        </p:txBody>
-      </p:sp>
-      <p:sp>
-        <p:nvSpPr>
-          <p:cNvPr id="27" name=""/>
+              <a:t>6</a:t>
+            </a:r>
+          </a:p>
+        </p:txBody>
+      </p:sp>
+      <p:sp>
+        <p:nvSpPr>
+          <p:cNvPr id="29" name=""/>
           <p:cNvSpPr/>
           <p:nvPr/>
         </p:nvSpPr>
         <p:spPr>
           <a:xfrm>
-            <a:off x="5419725" y="5019675"/>
-            <a:ext cx="2200275" cy="361950"/>
-          </a:xfrm>
-          <a:prstGeom prst="roundRect">
-            <a:avLst>
-              <a:gd name="adj" fmla="val 26316"/>
-            </a:avLst>
-          </a:prstGeom>
-          <a:solidFill>
-            <a:srgbClr val="FFFFFF"/>
-          </a:solidFill>
+            <a:off x="7715250" y="3295650"/>
+            <a:ext cx="3638550" cy="0"/>
+          </a:xfrm>
+          <a:prstGeom prst="line">
+            <a:avLst/>
+          </a:prstGeom>
+          <a:noFill/>
           <a:ln w="19050">
             <a:solidFill>
               <a:srgbClr val="F2D5E1"/>
@@ -1322,93 +1368,89 @@
       </p:sp>
       <p:sp>
         <p:nvSpPr>
-          <p:cNvPr id="28" name=""/>
-          <p:cNvSpPr txBox="1"/>
-          <p:nvPr/>
-        </p:nvSpPr>
-        <p:spPr>
-          <a:xfrm>
-            <a:off x="5734050" y="5114925"/>
-            <a:ext cx="1047750" cy="161925"/>
-          </a:xfrm>
-          <a:prstGeom prst="rect">
-            <a:avLst/>
-          </a:prstGeom>
-          <a:noFill/>
-          <a:ln/>
-        </p:spPr>
-        <p:txBody>
-          <a:bodyPr wrap="square" lIns="0" tIns="0" rIns="0" bIns="0" anchor="ctr"/>
-          <a:lstStyle/>
-          <a:p>
-            <a:pPr/>
-            <a:r>
-              <a:rPr sz="1200" b="1">
-                <a:solidFill>
-                  <a:srgbClr val="1E1A1C"/>
-                </a:solidFill>
-                <a:latin typeface="Arial"/>
-                <a:ea typeface="Arial"/>
-              </a:rPr>
-              <a:t>I might ~</a:t>
-            </a:r>
-          </a:p>
-        </p:txBody>
-      </p:sp>
-      <p:sp>
-        <p:nvSpPr>
-          <p:cNvPr id="29" name=""/>
-          <p:cNvSpPr txBox="1"/>
-          <p:nvPr/>
-        </p:nvSpPr>
-        <p:spPr>
-          <a:xfrm>
-            <a:off x="5553075" y="5114925"/>
-            <a:ext cx="438150" cy="161925"/>
-          </a:xfrm>
-          <a:prstGeom prst="rect">
-            <a:avLst/>
-          </a:prstGeom>
-          <a:noFill/>
-          <a:ln/>
-        </p:spPr>
-        <p:txBody>
-          <a:bodyPr wrap="square" lIns="0" tIns="0" rIns="0" bIns="0" anchor="ctr"/>
-          <a:lstStyle/>
-          <a:p>
-            <a:pPr/>
-            <a:r>
-              <a:rPr sz="1200" b="1">
+          <p:cNvPr id="30" name=""/>
+          <p:cNvSpPr txBox="1"/>
+          <p:nvPr/>
+        </p:nvSpPr>
+        <p:spPr>
+          <a:xfrm>
+            <a:off x="8058150" y="3390900"/>
+            <a:ext cx="2438400" cy="219075"/>
+          </a:xfrm>
+          <a:prstGeom prst="rect">
+            <a:avLst/>
+          </a:prstGeom>
+          <a:noFill/>
+          <a:ln/>
+        </p:spPr>
+        <p:txBody>
+          <a:bodyPr wrap="square" lIns="0" tIns="0" rIns="0" bIns="0" anchor="ctr"/>
+          <a:lstStyle/>
+          <a:p>
+            <a:pPr/>
+            <a:r>
+              <a:rPr sz="1600" b="1">
+                <a:solidFill>
+                  <a:srgbClr val="1E1A1C"/>
+                </a:solidFill>
+                <a:latin typeface="Arial"/>
+                <a:ea typeface="Arial"/>
+              </a:rPr>
+              <a:t>Do you mind if I ~?</a:t>
+            </a:r>
+          </a:p>
+        </p:txBody>
+      </p:sp>
+      <p:sp>
+        <p:nvSpPr>
+          <p:cNvPr id="31" name=""/>
+          <p:cNvSpPr txBox="1"/>
+          <p:nvPr/>
+        </p:nvSpPr>
+        <p:spPr>
+          <a:xfrm>
+            <a:off x="7715250" y="3390900"/>
+            <a:ext cx="476250" cy="219075"/>
+          </a:xfrm>
+          <a:prstGeom prst="rect">
+            <a:avLst/>
+          </a:prstGeom>
+          <a:noFill/>
+          <a:ln/>
+        </p:spPr>
+        <p:txBody>
+          <a:bodyPr wrap="square" lIns="0" tIns="0" rIns="0" bIns="0" anchor="ctr"/>
+          <a:lstStyle/>
+          <a:p>
+            <a:pPr/>
+            <a:r>
+              <a:rPr sz="1600" b="1">
                 <a:solidFill>
                   <a:srgbClr val="C8417F"/>
                 </a:solidFill>
                 <a:latin typeface="Arial"/>
                 <a:ea typeface="Arial"/>
               </a:rPr>
-              <a:t>6</a:t>
-            </a:r>
-          </a:p>
-        </p:txBody>
-      </p:sp>
-      <p:sp>
-        <p:nvSpPr>
-          <p:cNvPr id="30" name=""/>
+              <a:t>7</a:t>
+            </a:r>
+          </a:p>
+        </p:txBody>
+      </p:sp>
+      <p:sp>
+        <p:nvSpPr>
+          <p:cNvPr id="32" name=""/>
           <p:cNvSpPr/>
           <p:nvPr/>
         </p:nvSpPr>
         <p:spPr>
           <a:xfrm>
-            <a:off x="838200" y="5457825"/>
-            <a:ext cx="2200275" cy="361950"/>
-          </a:xfrm>
-          <a:prstGeom prst="roundRect">
-            <a:avLst>
-              <a:gd name="adj" fmla="val 26316"/>
-            </a:avLst>
-          </a:prstGeom>
-          <a:solidFill>
-            <a:srgbClr val="FFFFFF"/>
-          </a:solidFill>
+            <a:off x="7715250" y="3714750"/>
+            <a:ext cx="3638550" cy="0"/>
+          </a:xfrm>
+          <a:prstGeom prst="line">
+            <a:avLst/>
+          </a:prstGeom>
+          <a:noFill/>
           <a:ln w="19050">
             <a:solidFill>
               <a:srgbClr val="F2D5E1"/>
@@ -1419,93 +1461,89 @@
       </p:sp>
       <p:sp>
         <p:nvSpPr>
-          <p:cNvPr id="31" name=""/>
-          <p:cNvSpPr txBox="1"/>
-          <p:nvPr/>
-        </p:nvSpPr>
-        <p:spPr>
-          <a:xfrm>
-            <a:off x="1152525" y="5553075"/>
-            <a:ext cx="1885950" cy="161925"/>
-          </a:xfrm>
-          <a:prstGeom prst="rect">
-            <a:avLst/>
-          </a:prstGeom>
-          <a:noFill/>
-          <a:ln/>
-        </p:spPr>
-        <p:txBody>
-          <a:bodyPr wrap="square" lIns="0" tIns="0" rIns="0" bIns="0" anchor="ctr"/>
-          <a:lstStyle/>
-          <a:p>
-            <a:pPr/>
-            <a:r>
-              <a:rPr sz="1200" b="1">
-                <a:solidFill>
-                  <a:srgbClr val="1E1A1C"/>
-                </a:solidFill>
-                <a:latin typeface="Arial"/>
-                <a:ea typeface="Arial"/>
-              </a:rPr>
-              <a:t>Do you mind if I ~?</a:t>
-            </a:r>
-          </a:p>
-        </p:txBody>
-      </p:sp>
-      <p:sp>
-        <p:nvSpPr>
-          <p:cNvPr id="32" name=""/>
-          <p:cNvSpPr txBox="1"/>
-          <p:nvPr/>
-        </p:nvSpPr>
-        <p:spPr>
-          <a:xfrm>
-            <a:off x="971550" y="5553075"/>
-            <a:ext cx="438150" cy="161925"/>
-          </a:xfrm>
-          <a:prstGeom prst="rect">
-            <a:avLst/>
-          </a:prstGeom>
-          <a:noFill/>
-          <a:ln/>
-        </p:spPr>
-        <p:txBody>
-          <a:bodyPr wrap="square" lIns="0" tIns="0" rIns="0" bIns="0" anchor="ctr"/>
-          <a:lstStyle/>
-          <a:p>
-            <a:pPr/>
-            <a:r>
-              <a:rPr sz="1200" b="1">
+          <p:cNvPr id="33" name=""/>
+          <p:cNvSpPr txBox="1"/>
+          <p:nvPr/>
+        </p:nvSpPr>
+        <p:spPr>
+          <a:xfrm>
+            <a:off x="8058150" y="3810000"/>
+            <a:ext cx="1019175" cy="219075"/>
+          </a:xfrm>
+          <a:prstGeom prst="rect">
+            <a:avLst/>
+          </a:prstGeom>
+          <a:noFill/>
+          <a:ln/>
+        </p:spPr>
+        <p:txBody>
+          <a:bodyPr wrap="square" lIns="0" tIns="0" rIns="0" bIns="0" anchor="ctr"/>
+          <a:lstStyle/>
+          <a:p>
+            <a:pPr/>
+            <a:r>
+              <a:rPr sz="1600" b="1">
+                <a:solidFill>
+                  <a:srgbClr val="1E1A1C"/>
+                </a:solidFill>
+                <a:latin typeface="Arial"/>
+                <a:ea typeface="Arial"/>
+              </a:rPr>
+              <a:t>I bet ~</a:t>
+            </a:r>
+          </a:p>
+        </p:txBody>
+      </p:sp>
+      <p:sp>
+        <p:nvSpPr>
+          <p:cNvPr id="34" name=""/>
+          <p:cNvSpPr txBox="1"/>
+          <p:nvPr/>
+        </p:nvSpPr>
+        <p:spPr>
+          <a:xfrm>
+            <a:off x="7715250" y="3810000"/>
+            <a:ext cx="476250" cy="219075"/>
+          </a:xfrm>
+          <a:prstGeom prst="rect">
+            <a:avLst/>
+          </a:prstGeom>
+          <a:noFill/>
+          <a:ln/>
+        </p:spPr>
+        <p:txBody>
+          <a:bodyPr wrap="square" lIns="0" tIns="0" rIns="0" bIns="0" anchor="ctr"/>
+          <a:lstStyle/>
+          <a:p>
+            <a:pPr/>
+            <a:r>
+              <a:rPr sz="1600" b="1">
                 <a:solidFill>
                   <a:srgbClr val="C8417F"/>
                 </a:solidFill>
                 <a:latin typeface="Arial"/>
                 <a:ea typeface="Arial"/>
               </a:rPr>
-              <a:t>7</a:t>
-            </a:r>
-          </a:p>
-        </p:txBody>
-      </p:sp>
-      <p:sp>
-        <p:nvSpPr>
-          <p:cNvPr id="33" name=""/>
+              <a:t>8</a:t>
+            </a:r>
+          </a:p>
+        </p:txBody>
+      </p:sp>
+      <p:sp>
+        <p:nvSpPr>
+          <p:cNvPr id="35" name=""/>
           <p:cNvSpPr/>
           <p:nvPr/>
         </p:nvSpPr>
         <p:spPr>
           <a:xfrm>
-            <a:off x="3133725" y="5457825"/>
-            <a:ext cx="2200275" cy="361950"/>
-          </a:xfrm>
-          <a:prstGeom prst="roundRect">
-            <a:avLst>
-              <a:gd name="adj" fmla="val 26316"/>
-            </a:avLst>
-          </a:prstGeom>
-          <a:solidFill>
-            <a:srgbClr val="FFFFFF"/>
-          </a:solidFill>
+            <a:off x="7715250" y="4133850"/>
+            <a:ext cx="3638550" cy="0"/>
+          </a:xfrm>
+          <a:prstGeom prst="line">
+            <a:avLst/>
+          </a:prstGeom>
+          <a:noFill/>
           <a:ln w="19050">
             <a:solidFill>
               <a:srgbClr val="F2D5E1"/>
@@ -1516,132 +1554,70 @@
       </p:sp>
       <p:sp>
         <p:nvSpPr>
-          <p:cNvPr id="34" name=""/>
-          <p:cNvSpPr txBox="1"/>
-          <p:nvPr/>
-        </p:nvSpPr>
-        <p:spPr>
-          <a:xfrm>
-            <a:off x="3448050" y="5553075"/>
-            <a:ext cx="838200" cy="161925"/>
-          </a:xfrm>
-          <a:prstGeom prst="rect">
-            <a:avLst/>
-          </a:prstGeom>
-          <a:noFill/>
-          <a:ln/>
-        </p:spPr>
-        <p:txBody>
-          <a:bodyPr wrap="square" lIns="0" tIns="0" rIns="0" bIns="0" anchor="ctr"/>
-          <a:lstStyle/>
-          <a:p>
-            <a:pPr/>
-            <a:r>
-              <a:rPr sz="1200" b="1">
-                <a:solidFill>
-                  <a:srgbClr val="1E1A1C"/>
-                </a:solidFill>
-                <a:latin typeface="Arial"/>
-                <a:ea typeface="Arial"/>
-              </a:rPr>
-              <a:t>I bet ~</a:t>
-            </a:r>
-          </a:p>
-        </p:txBody>
-      </p:sp>
-      <p:sp>
-        <p:nvSpPr>
-          <p:cNvPr id="35" name=""/>
-          <p:cNvSpPr txBox="1"/>
-          <p:nvPr/>
-        </p:nvSpPr>
-        <p:spPr>
-          <a:xfrm>
-            <a:off x="3267075" y="5553075"/>
-            <a:ext cx="438150" cy="161925"/>
-          </a:xfrm>
-          <a:prstGeom prst="rect">
-            <a:avLst/>
-          </a:prstGeom>
-          <a:noFill/>
-          <a:ln/>
-        </p:spPr>
-        <p:txBody>
-          <a:bodyPr wrap="square" lIns="0" tIns="0" rIns="0" bIns="0" anchor="ctr"/>
-          <a:lstStyle/>
-          <a:p>
-            <a:pPr/>
-            <a:r>
-              <a:rPr sz="1200" b="1">
+          <p:cNvPr id="36" name=""/>
+          <p:cNvSpPr txBox="1"/>
+          <p:nvPr/>
+        </p:nvSpPr>
+        <p:spPr>
+          <a:xfrm>
+            <a:off x="8058150" y="4229100"/>
+            <a:ext cx="1866900" cy="219075"/>
+          </a:xfrm>
+          <a:prstGeom prst="rect">
+            <a:avLst/>
+          </a:prstGeom>
+          <a:noFill/>
+          <a:ln/>
+        </p:spPr>
+        <p:txBody>
+          <a:bodyPr wrap="square" lIns="0" tIns="0" rIns="0" bIns="0" anchor="ctr"/>
+          <a:lstStyle/>
+          <a:p>
+            <a:pPr/>
+            <a:r>
+              <a:rPr sz="1600" b="1">
+                <a:solidFill>
+                  <a:srgbClr val="1E1A1C"/>
+                </a:solidFill>
+                <a:latin typeface="Arial"/>
+                <a:ea typeface="Arial"/>
+              </a:rPr>
+              <a:t>I'm trying to ~</a:t>
+            </a:r>
+          </a:p>
+        </p:txBody>
+      </p:sp>
+      <p:sp>
+        <p:nvSpPr>
+          <p:cNvPr id="37" name=""/>
+          <p:cNvSpPr txBox="1"/>
+          <p:nvPr/>
+        </p:nvSpPr>
+        <p:spPr>
+          <a:xfrm>
+            <a:off x="7715250" y="4229100"/>
+            <a:ext cx="476250" cy="219075"/>
+          </a:xfrm>
+          <a:prstGeom prst="rect">
+            <a:avLst/>
+          </a:prstGeom>
+          <a:noFill/>
+          <a:ln/>
+        </p:spPr>
+        <p:txBody>
+          <a:bodyPr wrap="square" lIns="0" tIns="0" rIns="0" bIns="0" anchor="ctr"/>
+          <a:lstStyle/>
+          <a:p>
+            <a:pPr/>
+            <a:r>
+              <a:rPr sz="1600" b="1">
                 <a:solidFill>
                   <a:srgbClr val="C8417F"/>
                 </a:solidFill>
                 <a:latin typeface="Arial"/>
                 <a:ea typeface="Arial"/>
               </a:rPr>
-              <a:t>8</a:t>
-            </a:r>
-          </a:p>
-        </p:txBody>
-      </p:sp>
-      <p:sp>
-        <p:nvSpPr>
-          <p:cNvPr id="36" name=""/>
-          <p:cNvSpPr/>
-          <p:nvPr/>
-        </p:nvSpPr>
-        <p:spPr>
-          <a:xfrm>
-            <a:off x="5419725" y="5457825"/>
-            <a:ext cx="2200275" cy="361950"/>
-          </a:xfrm>
-          <a:prstGeom prst="roundRect">
-            <a:avLst>
-              <a:gd name="adj" fmla="val 26316"/>
-            </a:avLst>
-          </a:prstGeom>
-          <a:solidFill>
-            <a:srgbClr val="FFFFFF"/>
-          </a:solidFill>
-          <a:ln w="19050">
-            <a:solidFill>
-              <a:srgbClr val="F2D5E1"/>
-            </a:solidFill>
-            <a:prstDash val="solid"/>
-          </a:ln>
-        </p:spPr>
-      </p:sp>
-      <p:sp>
-        <p:nvSpPr>
-          <p:cNvPr id="37" name=""/>
-          <p:cNvSpPr txBox="1"/>
-          <p:nvPr/>
-        </p:nvSpPr>
-        <p:spPr>
-          <a:xfrm>
-            <a:off x="5734050" y="5553075"/>
-            <a:ext cx="1457325" cy="161925"/>
-          </a:xfrm>
-          <a:prstGeom prst="rect">
-            <a:avLst/>
-          </a:prstGeom>
-          <a:noFill/>
-          <a:ln/>
-        </p:spPr>
-        <p:txBody>
-          <a:bodyPr wrap="square" lIns="0" tIns="0" rIns="0" bIns="0" anchor="ctr"/>
-          <a:lstStyle/>
-          <a:p>
-            <a:pPr/>
-            <a:r>
-              <a:rPr sz="1200" b="1">
-                <a:solidFill>
-                  <a:srgbClr val="1E1A1C"/>
-                </a:solidFill>
-                <a:latin typeface="Arial"/>
-                <a:ea typeface="Arial"/>
-              </a:rPr>
-              <a:t>I'm trying to ~</a:t>
+              <a:t>9</a:t>
             </a:r>
           </a:p>
         </p:txBody>
@@ -1654,42 +1630,7 @@
         </p:nvSpPr>
         <p:spPr>
           <a:xfrm>
-            <a:off x="5553075" y="5553075"/>
-            <a:ext cx="438150" cy="161925"/>
-          </a:xfrm>
-          <a:prstGeom prst="rect">
-            <a:avLst/>
-          </a:prstGeom>
-          <a:noFill/>
-          <a:ln/>
-        </p:spPr>
-        <p:txBody>
-          <a:bodyPr wrap="square" lIns="0" tIns="0" rIns="0" bIns="0" anchor="ctr"/>
-          <a:lstStyle/>
-          <a:p>
-            <a:pPr/>
-            <a:r>
-              <a:rPr sz="1200" b="1">
-                <a:solidFill>
-                  <a:srgbClr val="C8417F"/>
-                </a:solidFill>
-                <a:latin typeface="Arial"/>
-                <a:ea typeface="Arial"/>
-              </a:rPr>
-              <a:t>9</a:t>
-            </a:r>
-          </a:p>
-        </p:txBody>
-      </p:sp>
-      <p:sp>
-        <p:nvSpPr>
-          <p:cNvPr id="39" name=""/>
-          <p:cNvSpPr txBox="1"/>
-          <p:nvPr/>
-        </p:nvSpPr>
-        <p:spPr>
-          <a:xfrm>
-            <a:off x="838200" y="5934075"/>
+            <a:off x="7715250" y="4657725"/>
             <a:ext cx="3038475" cy="228600"/>
           </a:xfrm>
           <a:prstGeom prst="rect">
@@ -4790,9 +4731,33 @@
           <a:ln/>
         </p:spPr>
       </p:sp>
-      <p:sp>
-        <p:nvSpPr>
-          <p:cNvPr id="3" name=""/>
+      <p:pic>
+        <p:nvPicPr>
+          <p:cNvPr id="3" name="Image 0" descr="手を振るキャラクター">    </p:cNvPr>
+          <p:cNvPicPr>
+            <a:picLocks noChangeAspect="1"/>
+          </p:cNvPicPr>
+          <p:nvPr/>
+        </p:nvPicPr>
+        <p:blipFill>
+          <a:blip r:embed="rId1"/>
+          <a:stretch>
+            <a:fillRect/>
+          </a:stretch>
+        </p:blipFill>
+        <p:spPr>
+          <a:xfrm>
+            <a:off x="10563225" y="5143500"/>
+            <a:ext cx="1285875" cy="1714500"/>
+          </a:xfrm>
+          <a:prstGeom prst="rect">
+            <a:avLst/>
+          </a:prstGeom>
+        </p:spPr>
+      </p:pic>
+      <p:sp>
+        <p:nvSpPr>
+          <p:cNvPr id="4" name=""/>
           <p:cNvSpPr txBox="1"/>
           <p:nvPr/>
         </p:nvSpPr>
@@ -4827,7 +4792,7 @@
       </p:sp>
       <p:sp>
         <p:nvSpPr>
-          <p:cNvPr id="4" name=""/>
+          <p:cNvPr id="5" name=""/>
           <p:cNvSpPr txBox="1"/>
           <p:nvPr/>
         </p:nvSpPr>
@@ -4862,7 +4827,7 @@
       </p:sp>
       <p:sp>
         <p:nvSpPr>
-          <p:cNvPr id="5" name=""/>
+          <p:cNvPr id="6" name=""/>
           <p:cNvSpPr/>
           <p:nvPr/>
         </p:nvSpPr>
@@ -4884,7 +4849,7 @@
       </p:sp>
       <p:sp>
         <p:nvSpPr>
-          <p:cNvPr id="6" name=""/>
+          <p:cNvPr id="7" name=""/>
           <p:cNvSpPr txBox="1"/>
           <p:nvPr/>
         </p:nvSpPr>
@@ -4919,7 +4884,7 @@
       </p:sp>
       <p:sp>
         <p:nvSpPr>
-          <p:cNvPr id="7" name=""/>
+          <p:cNvPr id="8" name=""/>
           <p:cNvSpPr/>
           <p:nvPr/>
         </p:nvSpPr>
@@ -4939,7 +4904,7 @@
       </p:sp>
       <p:sp>
         <p:nvSpPr>
-          <p:cNvPr id="8" name=""/>
+          <p:cNvPr id="9" name=""/>
           <p:cNvSpPr txBox="1"/>
           <p:nvPr/>
         </p:nvSpPr>
@@ -4974,7 +4939,7 @@
       </p:sp>
       <p:sp>
         <p:nvSpPr>
-          <p:cNvPr id="9" name=""/>
+          <p:cNvPr id="10" name=""/>
           <p:cNvSpPr txBox="1"/>
           <p:nvPr/>
         </p:nvSpPr>
@@ -5009,7 +4974,7 @@
       </p:sp>
       <p:sp>
         <p:nvSpPr>
-          <p:cNvPr id="10" name=""/>
+          <p:cNvPr id="11" name=""/>
           <p:cNvSpPr/>
           <p:nvPr/>
         </p:nvSpPr>
@@ -5029,7 +4994,7 @@
       </p:sp>
       <p:sp>
         <p:nvSpPr>
-          <p:cNvPr id="11" name=""/>
+          <p:cNvPr id="12" name=""/>
           <p:cNvSpPr txBox="1"/>
           <p:nvPr/>
         </p:nvSpPr>
@@ -5064,7 +5029,7 @@
       </p:sp>
       <p:sp>
         <p:nvSpPr>
-          <p:cNvPr id="12" name=""/>
+          <p:cNvPr id="13" name=""/>
           <p:cNvSpPr txBox="1"/>
           <p:nvPr/>
         </p:nvSpPr>
@@ -5099,7 +5064,7 @@
       </p:sp>
       <p:sp>
         <p:nvSpPr>
-          <p:cNvPr id="13" name=""/>
+          <p:cNvPr id="14" name=""/>
           <p:cNvSpPr/>
           <p:nvPr/>
         </p:nvSpPr>
@@ -5119,7 +5084,7 @@
       </p:sp>
       <p:sp>
         <p:nvSpPr>
-          <p:cNvPr id="14" name=""/>
+          <p:cNvPr id="15" name=""/>
           <p:cNvSpPr txBox="1"/>
           <p:nvPr/>
         </p:nvSpPr>
@@ -5154,7 +5119,7 @@
       </p:sp>
       <p:sp>
         <p:nvSpPr>
-          <p:cNvPr id="15" name=""/>
+          <p:cNvPr id="16" name=""/>
           <p:cNvSpPr txBox="1"/>
           <p:nvPr/>
         </p:nvSpPr>
@@ -13255,9 +13220,33 @@
           <a:ln/>
         </p:spPr>
       </p:sp>
-      <p:sp>
-        <p:nvSpPr>
-          <p:cNvPr id="3" name=""/>
+      <p:pic>
+        <p:nvPicPr>
+          <p:cNvPr id="3" name="Image 0" descr="手を振るキャラクター">    </p:cNvPr>
+          <p:cNvPicPr>
+            <a:picLocks noChangeAspect="1"/>
+          </p:cNvPicPr>
+          <p:nvPr/>
+        </p:nvPicPr>
+        <p:blipFill>
+          <a:blip r:embed="rId1"/>
+          <a:stretch>
+            <a:fillRect/>
+          </a:stretch>
+        </p:blipFill>
+        <p:spPr>
+          <a:xfrm>
+            <a:off x="10563225" y="5143500"/>
+            <a:ext cx="1285875" cy="1714500"/>
+          </a:xfrm>
+          <a:prstGeom prst="rect">
+            <a:avLst/>
+          </a:prstGeom>
+        </p:spPr>
+      </p:pic>
+      <p:sp>
+        <p:nvSpPr>
+          <p:cNvPr id="4" name=""/>
           <p:cNvSpPr txBox="1"/>
           <p:nvPr/>
         </p:nvSpPr>
@@ -13292,7 +13281,7 @@
       </p:sp>
       <p:sp>
         <p:nvSpPr>
-          <p:cNvPr id="4" name=""/>
+          <p:cNvPr id="5" name=""/>
           <p:cNvSpPr txBox="1"/>
           <p:nvPr/>
         </p:nvSpPr>
@@ -13349,7 +13338,7 @@
       </p:sp>
       <p:sp>
         <p:nvSpPr>
-          <p:cNvPr id="5" name=""/>
+          <p:cNvPr id="6" name=""/>
           <p:cNvSpPr/>
           <p:nvPr/>
         </p:nvSpPr>
@@ -13371,7 +13360,7 @@
       </p:sp>
       <p:sp>
         <p:nvSpPr>
-          <p:cNvPr id="6" name=""/>
+          <p:cNvPr id="7" name=""/>
           <p:cNvSpPr txBox="1"/>
           <p:nvPr/>
         </p:nvSpPr>
@@ -13406,7 +13395,7 @@
       </p:sp>
       <p:sp>
         <p:nvSpPr>
-          <p:cNvPr id="7" name=""/>
+          <p:cNvPr id="8" name=""/>
           <p:cNvSpPr txBox="1"/>
           <p:nvPr/>
         </p:nvSpPr>
@@ -13452,7 +13441,7 @@
       </p:sp>
       <p:sp>
         <p:nvSpPr>
-          <p:cNvPr id="8" name=""/>
+          <p:cNvPr id="9" name=""/>
           <p:cNvSpPr txBox="1"/>
           <p:nvPr/>
         </p:nvSpPr>
@@ -13487,7 +13476,7 @@
       </p:sp>
       <p:sp>
         <p:nvSpPr>
-          <p:cNvPr id="9" name=""/>
+          <p:cNvPr id="10" name=""/>
           <p:cNvSpPr txBox="1"/>
           <p:nvPr/>
         </p:nvSpPr>
@@ -13522,7 +13511,7 @@
       </p:sp>
       <p:sp>
         <p:nvSpPr>
-          <p:cNvPr id="10" name=""/>
+          <p:cNvPr id="11" name=""/>
           <p:cNvSpPr txBox="1"/>
           <p:nvPr/>
         </p:nvSpPr>
@@ -13571,7 +13560,7 @@
       </p:sp>
       <p:sp>
         <p:nvSpPr>
-          <p:cNvPr id="11" name=""/>
+          <p:cNvPr id="12" name=""/>
           <p:cNvSpPr txBox="1"/>
           <p:nvPr/>
         </p:nvSpPr>
@@ -13606,7 +13595,7 @@
       </p:sp>
       <p:sp>
         <p:nvSpPr>
-          <p:cNvPr id="12" name=""/>
+          <p:cNvPr id="13" name=""/>
           <p:cNvSpPr txBox="1"/>
           <p:nvPr/>
         </p:nvSpPr>
@@ -13655,7 +13644,7 @@
       </p:sp>
       <p:sp>
         <p:nvSpPr>
-          <p:cNvPr id="13" name=""/>
+          <p:cNvPr id="14" name=""/>
           <p:cNvSpPr txBox="1"/>
           <p:nvPr/>
         </p:nvSpPr>
@@ -13690,7 +13679,7 @@
       </p:sp>
       <p:sp>
         <p:nvSpPr>
-          <p:cNvPr id="14" name=""/>
+          <p:cNvPr id="15" name=""/>
           <p:cNvSpPr txBox="1"/>
           <p:nvPr/>
         </p:nvSpPr>
@@ -13739,7 +13728,7 @@
       </p:sp>
       <p:sp>
         <p:nvSpPr>
-          <p:cNvPr id="15" name=""/>
+          <p:cNvPr id="16" name=""/>
           <p:cNvSpPr txBox="1"/>
           <p:nvPr/>
         </p:nvSpPr>
@@ -13774,7 +13763,7 @@
       </p:sp>
       <p:sp>
         <p:nvSpPr>
-          <p:cNvPr id="16" name=""/>
+          <p:cNvPr id="17" name=""/>
           <p:cNvSpPr txBox="1"/>
           <p:nvPr/>
         </p:nvSpPr>
@@ -13823,7 +13812,7 @@
       </p:sp>
       <p:sp>
         <p:nvSpPr>
-          <p:cNvPr id="17" name=""/>
+          <p:cNvPr id="18" name=""/>
           <p:cNvSpPr txBox="1"/>
           <p:nvPr/>
         </p:nvSpPr>
@@ -13858,7 +13847,7 @@
       </p:sp>
       <p:sp>
         <p:nvSpPr>
-          <p:cNvPr id="18" name=""/>
+          <p:cNvPr id="19" name=""/>
           <p:cNvSpPr txBox="1"/>
           <p:nvPr/>
         </p:nvSpPr>
@@ -13907,7 +13896,7 @@
       </p:sp>
       <p:sp>
         <p:nvSpPr>
-          <p:cNvPr id="19" name=""/>
+          <p:cNvPr id="20" name=""/>
           <p:cNvSpPr/>
           <p:nvPr/>
         </p:nvSpPr>
@@ -13930,7 +13919,7 @@
       </p:sp>
       <p:sp>
         <p:nvSpPr>
-          <p:cNvPr id="20" name=""/>
+          <p:cNvPr id="21" name=""/>
           <p:cNvSpPr txBox="1"/>
           <p:nvPr/>
         </p:nvSpPr>
@@ -13965,7 +13954,7 @@
       </p:sp>
       <p:sp>
         <p:nvSpPr>
-          <p:cNvPr id="21" name=""/>
+          <p:cNvPr id="22" name=""/>
           <p:cNvSpPr txBox="1"/>
           <p:nvPr/>
         </p:nvSpPr>
@@ -14011,7 +14000,7 @@
       </p:sp>
       <p:sp>
         <p:nvSpPr>
-          <p:cNvPr id="22" name=""/>
+          <p:cNvPr id="23" name=""/>
           <p:cNvSpPr txBox="1"/>
           <p:nvPr/>
         </p:nvSpPr>
@@ -14046,7 +14035,7 @@
       </p:sp>
       <p:sp>
         <p:nvSpPr>
-          <p:cNvPr id="23" name=""/>
+          <p:cNvPr id="24" name=""/>
           <p:cNvSpPr txBox="1"/>
           <p:nvPr/>
         </p:nvSpPr>
@@ -14081,7 +14070,7 @@
       </p:sp>
       <p:sp>
         <p:nvSpPr>
-          <p:cNvPr id="24" name=""/>
+          <p:cNvPr id="25" name=""/>
           <p:cNvSpPr txBox="1"/>
           <p:nvPr/>
         </p:nvSpPr>
@@ -14130,7 +14119,7 @@
       </p:sp>
       <p:sp>
         <p:nvSpPr>
-          <p:cNvPr id="25" name=""/>
+          <p:cNvPr id="26" name=""/>
           <p:cNvSpPr txBox="1"/>
           <p:nvPr/>
         </p:nvSpPr>
@@ -14165,7 +14154,7 @@
       </p:sp>
       <p:sp>
         <p:nvSpPr>
-          <p:cNvPr id="26" name=""/>
+          <p:cNvPr id="27" name=""/>
           <p:cNvSpPr txBox="1"/>
           <p:nvPr/>
         </p:nvSpPr>
@@ -14214,7 +14203,7 @@
       </p:sp>
       <p:sp>
         <p:nvSpPr>
-          <p:cNvPr id="27" name=""/>
+          <p:cNvPr id="28" name=""/>
           <p:cNvSpPr txBox="1"/>
           <p:nvPr/>
         </p:nvSpPr>
@@ -14249,7 +14238,7 @@
       </p:sp>
       <p:sp>
         <p:nvSpPr>
-          <p:cNvPr id="28" name=""/>
+          <p:cNvPr id="29" name=""/>
           <p:cNvSpPr txBox="1"/>
           <p:nvPr/>
         </p:nvSpPr>
@@ -14298,7 +14287,7 @@
       </p:sp>
       <p:sp>
         <p:nvSpPr>
-          <p:cNvPr id="29" name=""/>
+          <p:cNvPr id="30" name=""/>
           <p:cNvSpPr txBox="1"/>
           <p:nvPr/>
         </p:nvSpPr>
@@ -14333,7 +14322,7 @@
       </p:sp>
       <p:sp>
         <p:nvSpPr>
-          <p:cNvPr id="30" name=""/>
+          <p:cNvPr id="31" name=""/>
           <p:cNvSpPr txBox="1"/>
           <p:nvPr/>
         </p:nvSpPr>
@@ -14382,7 +14371,7 @@
       </p:sp>
       <p:sp>
         <p:nvSpPr>
-          <p:cNvPr id="31" name=""/>
+          <p:cNvPr id="32" name=""/>
           <p:cNvSpPr txBox="1"/>
           <p:nvPr/>
         </p:nvSpPr>
@@ -14417,7 +14406,7 @@
       </p:sp>
       <p:sp>
         <p:nvSpPr>
-          <p:cNvPr id="32" name=""/>
+          <p:cNvPr id="33" name=""/>
           <p:cNvSpPr txBox="1"/>
           <p:nvPr/>
         </p:nvSpPr>
@@ -14466,7 +14455,7 @@
       </p:sp>
       <p:sp>
         <p:nvSpPr>
-          <p:cNvPr id="33" name=""/>
+          <p:cNvPr id="34" name=""/>
           <p:cNvSpPr/>
           <p:nvPr/>
         </p:nvSpPr>
@@ -14489,7 +14478,7 @@
       </p:sp>
       <p:sp>
         <p:nvSpPr>
-          <p:cNvPr id="34" name=""/>
+          <p:cNvPr id="35" name=""/>
           <p:cNvSpPr txBox="1"/>
           <p:nvPr/>
         </p:nvSpPr>
@@ -14524,7 +14513,7 @@
       </p:sp>
       <p:sp>
         <p:nvSpPr>
-          <p:cNvPr id="35" name=""/>
+          <p:cNvPr id="36" name=""/>
           <p:cNvSpPr txBox="1"/>
           <p:nvPr/>
         </p:nvSpPr>
@@ -14570,7 +14559,7 @@
       </p:sp>
       <p:sp>
         <p:nvSpPr>
-          <p:cNvPr id="36" name=""/>
+          <p:cNvPr id="37" name=""/>
           <p:cNvSpPr txBox="1"/>
           <p:nvPr/>
         </p:nvSpPr>
@@ -14605,7 +14594,7 @@
       </p:sp>
       <p:sp>
         <p:nvSpPr>
-          <p:cNvPr id="37" name=""/>
+          <p:cNvPr id="38" name=""/>
           <p:cNvSpPr txBox="1"/>
           <p:nvPr/>
         </p:nvSpPr>
@@ -14640,7 +14629,7 @@
       </p:sp>
       <p:sp>
         <p:nvSpPr>
-          <p:cNvPr id="38" name=""/>
+          <p:cNvPr id="39" name=""/>
           <p:cNvSpPr txBox="1"/>
           <p:nvPr/>
         </p:nvSpPr>
@@ -14689,7 +14678,7 @@
       </p:sp>
       <p:sp>
         <p:nvSpPr>
-          <p:cNvPr id="39" name=""/>
+          <p:cNvPr id="40" name=""/>
           <p:cNvSpPr txBox="1"/>
           <p:nvPr/>
         </p:nvSpPr>
@@ -14724,7 +14713,7 @@
       </p:sp>
       <p:sp>
         <p:nvSpPr>
-          <p:cNvPr id="40" name=""/>
+          <p:cNvPr id="41" name=""/>
           <p:cNvSpPr txBox="1"/>
           <p:nvPr/>
         </p:nvSpPr>
@@ -14773,7 +14762,7 @@
       </p:sp>
       <p:sp>
         <p:nvSpPr>
-          <p:cNvPr id="41" name=""/>
+          <p:cNvPr id="42" name=""/>
           <p:cNvSpPr txBox="1"/>
           <p:nvPr/>
         </p:nvSpPr>
@@ -14808,7 +14797,7 @@
       </p:sp>
       <p:sp>
         <p:nvSpPr>
-          <p:cNvPr id="42" name=""/>
+          <p:cNvPr id="43" name=""/>
           <p:cNvSpPr txBox="1"/>
           <p:nvPr/>
         </p:nvSpPr>
@@ -14857,7 +14846,7 @@
       </p:sp>
       <p:sp>
         <p:nvSpPr>
-          <p:cNvPr id="43" name=""/>
+          <p:cNvPr id="44" name=""/>
           <p:cNvSpPr txBox="1"/>
           <p:nvPr/>
         </p:nvSpPr>
@@ -14892,7 +14881,7 @@
       </p:sp>
       <p:sp>
         <p:nvSpPr>
-          <p:cNvPr id="44" name=""/>
+          <p:cNvPr id="45" name=""/>
           <p:cNvSpPr txBox="1"/>
           <p:nvPr/>
         </p:nvSpPr>
@@ -14941,7 +14930,7 @@
       </p:sp>
       <p:sp>
         <p:nvSpPr>
-          <p:cNvPr id="45" name=""/>
+          <p:cNvPr id="46" name=""/>
           <p:cNvSpPr txBox="1"/>
           <p:nvPr/>
         </p:nvSpPr>
@@ -14976,7 +14965,7 @@
       </p:sp>
       <p:sp>
         <p:nvSpPr>
-          <p:cNvPr id="46" name=""/>
+          <p:cNvPr id="47" name=""/>
           <p:cNvSpPr txBox="1"/>
           <p:nvPr/>
         </p:nvSpPr>
@@ -15100,9 +15089,33 @@
           <a:ln/>
         </p:spPr>
       </p:sp>
-      <p:sp>
-        <p:nvSpPr>
-          <p:cNvPr id="3" name=""/>
+      <p:pic>
+        <p:nvPicPr>
+          <p:cNvPr id="3" name="Image 0" descr="手を振るキャラクター">    </p:cNvPr>
+          <p:cNvPicPr>
+            <a:picLocks noChangeAspect="1"/>
+          </p:cNvPicPr>
+          <p:nvPr/>
+        </p:nvPicPr>
+        <p:blipFill>
+          <a:blip r:embed="rId1"/>
+          <a:stretch>
+            <a:fillRect/>
+          </a:stretch>
+        </p:blipFill>
+        <p:spPr>
+          <a:xfrm>
+            <a:off x="10563225" y="5143500"/>
+            <a:ext cx="1285875" cy="1714500"/>
+          </a:xfrm>
+          <a:prstGeom prst="rect">
+            <a:avLst/>
+          </a:prstGeom>
+        </p:spPr>
+      </p:pic>
+      <p:sp>
+        <p:nvSpPr>
+          <p:cNvPr id="4" name=""/>
           <p:cNvSpPr txBox="1"/>
           <p:nvPr/>
         </p:nvSpPr>
@@ -15137,7 +15150,7 @@
       </p:sp>
       <p:sp>
         <p:nvSpPr>
-          <p:cNvPr id="4" name=""/>
+          <p:cNvPr id="5" name=""/>
           <p:cNvSpPr txBox="1"/>
           <p:nvPr/>
         </p:nvSpPr>
@@ -15194,7 +15207,7 @@
       </p:sp>
       <p:sp>
         <p:nvSpPr>
-          <p:cNvPr id="5" name=""/>
+          <p:cNvPr id="6" name=""/>
           <p:cNvSpPr/>
           <p:nvPr/>
         </p:nvSpPr>
@@ -15216,7 +15229,7 @@
       </p:sp>
       <p:sp>
         <p:nvSpPr>
-          <p:cNvPr id="6" name=""/>
+          <p:cNvPr id="7" name=""/>
           <p:cNvSpPr txBox="1"/>
           <p:nvPr/>
         </p:nvSpPr>
@@ -15251,7 +15264,7 @@
       </p:sp>
       <p:sp>
         <p:nvSpPr>
-          <p:cNvPr id="7" name=""/>
+          <p:cNvPr id="8" name=""/>
           <p:cNvSpPr txBox="1"/>
           <p:nvPr/>
         </p:nvSpPr>
@@ -15308,7 +15321,7 @@
       </p:sp>
       <p:sp>
         <p:nvSpPr>
-          <p:cNvPr id="8" name=""/>
+          <p:cNvPr id="9" name=""/>
           <p:cNvSpPr txBox="1"/>
           <p:nvPr/>
         </p:nvSpPr>
@@ -15343,7 +15356,7 @@
       </p:sp>
       <p:sp>
         <p:nvSpPr>
-          <p:cNvPr id="9" name=""/>
+          <p:cNvPr id="10" name=""/>
           <p:cNvSpPr txBox="1"/>
           <p:nvPr/>
         </p:nvSpPr>
@@ -15378,7 +15391,7 @@
       </p:sp>
       <p:sp>
         <p:nvSpPr>
-          <p:cNvPr id="10" name=""/>
+          <p:cNvPr id="11" name=""/>
           <p:cNvSpPr txBox="1"/>
           <p:nvPr/>
         </p:nvSpPr>
@@ -15427,7 +15440,7 @@
       </p:sp>
       <p:sp>
         <p:nvSpPr>
-          <p:cNvPr id="11" name=""/>
+          <p:cNvPr id="12" name=""/>
           <p:cNvSpPr txBox="1"/>
           <p:nvPr/>
         </p:nvSpPr>
@@ -15462,7 +15475,7 @@
       </p:sp>
       <p:sp>
         <p:nvSpPr>
-          <p:cNvPr id="12" name=""/>
+          <p:cNvPr id="13" name=""/>
           <p:cNvSpPr txBox="1"/>
           <p:nvPr/>
         </p:nvSpPr>
@@ -15511,7 +15524,7 @@
       </p:sp>
       <p:sp>
         <p:nvSpPr>
-          <p:cNvPr id="13" name=""/>
+          <p:cNvPr id="14" name=""/>
           <p:cNvSpPr txBox="1"/>
           <p:nvPr/>
         </p:nvSpPr>
@@ -15546,7 +15559,7 @@
       </p:sp>
       <p:sp>
         <p:nvSpPr>
-          <p:cNvPr id="14" name=""/>
+          <p:cNvPr id="15" name=""/>
           <p:cNvSpPr txBox="1"/>
           <p:nvPr/>
         </p:nvSpPr>
@@ -15595,7 +15608,7 @@
       </p:sp>
       <p:sp>
         <p:nvSpPr>
-          <p:cNvPr id="15" name=""/>
+          <p:cNvPr id="16" name=""/>
           <p:cNvSpPr txBox="1"/>
           <p:nvPr/>
         </p:nvSpPr>
@@ -15630,7 +15643,7 @@
       </p:sp>
       <p:sp>
         <p:nvSpPr>
-          <p:cNvPr id="16" name=""/>
+          <p:cNvPr id="17" name=""/>
           <p:cNvSpPr txBox="1"/>
           <p:nvPr/>
         </p:nvSpPr>
@@ -15679,7 +15692,7 @@
       </p:sp>
       <p:sp>
         <p:nvSpPr>
-          <p:cNvPr id="17" name=""/>
+          <p:cNvPr id="18" name=""/>
           <p:cNvSpPr txBox="1"/>
           <p:nvPr/>
         </p:nvSpPr>
@@ -15714,7 +15727,7 @@
       </p:sp>
       <p:sp>
         <p:nvSpPr>
-          <p:cNvPr id="18" name=""/>
+          <p:cNvPr id="19" name=""/>
           <p:cNvSpPr txBox="1"/>
           <p:nvPr/>
         </p:nvSpPr>
@@ -15763,7 +15776,7 @@
       </p:sp>
       <p:sp>
         <p:nvSpPr>
-          <p:cNvPr id="19" name=""/>
+          <p:cNvPr id="20" name=""/>
           <p:cNvSpPr/>
           <p:nvPr/>
         </p:nvSpPr>
@@ -15786,7 +15799,7 @@
       </p:sp>
       <p:sp>
         <p:nvSpPr>
-          <p:cNvPr id="20" name=""/>
+          <p:cNvPr id="21" name=""/>
           <p:cNvSpPr txBox="1"/>
           <p:nvPr/>
         </p:nvSpPr>
@@ -15821,7 +15834,7 @@
       </p:sp>
       <p:sp>
         <p:nvSpPr>
-          <p:cNvPr id="21" name=""/>
+          <p:cNvPr id="22" name=""/>
           <p:cNvSpPr txBox="1"/>
           <p:nvPr/>
         </p:nvSpPr>
@@ -15867,7 +15880,7 @@
       </p:sp>
       <p:sp>
         <p:nvSpPr>
-          <p:cNvPr id="22" name=""/>
+          <p:cNvPr id="23" name=""/>
           <p:cNvSpPr txBox="1"/>
           <p:nvPr/>
         </p:nvSpPr>
@@ -15902,7 +15915,7 @@
       </p:sp>
       <p:sp>
         <p:nvSpPr>
-          <p:cNvPr id="23" name=""/>
+          <p:cNvPr id="24" name=""/>
           <p:cNvSpPr txBox="1"/>
           <p:nvPr/>
         </p:nvSpPr>
@@ -15937,7 +15950,7 @@
       </p:sp>
       <p:sp>
         <p:nvSpPr>
-          <p:cNvPr id="24" name=""/>
+          <p:cNvPr id="25" name=""/>
           <p:cNvSpPr txBox="1"/>
           <p:nvPr/>
         </p:nvSpPr>
@@ -15986,7 +15999,7 @@
       </p:sp>
       <p:sp>
         <p:nvSpPr>
-          <p:cNvPr id="25" name=""/>
+          <p:cNvPr id="26" name=""/>
           <p:cNvSpPr txBox="1"/>
           <p:nvPr/>
         </p:nvSpPr>
@@ -16021,7 +16034,7 @@
       </p:sp>
       <p:sp>
         <p:nvSpPr>
-          <p:cNvPr id="26" name=""/>
+          <p:cNvPr id="27" name=""/>
           <p:cNvSpPr txBox="1"/>
           <p:nvPr/>
         </p:nvSpPr>
@@ -16056,7 +16069,7 @@
       </p:sp>
       <p:sp>
         <p:nvSpPr>
-          <p:cNvPr id="27" name=""/>
+          <p:cNvPr id="28" name=""/>
           <p:cNvSpPr txBox="1"/>
           <p:nvPr/>
         </p:nvSpPr>
@@ -16105,7 +16118,7 @@
       </p:sp>
       <p:sp>
         <p:nvSpPr>
-          <p:cNvPr id="28" name=""/>
+          <p:cNvPr id="29" name=""/>
           <p:cNvSpPr txBox="1"/>
           <p:nvPr/>
         </p:nvSpPr>
@@ -16140,7 +16153,7 @@
       </p:sp>
       <p:sp>
         <p:nvSpPr>
-          <p:cNvPr id="29" name=""/>
+          <p:cNvPr id="30" name=""/>
           <p:cNvSpPr txBox="1"/>
           <p:nvPr/>
         </p:nvSpPr>
@@ -16175,7 +16188,7 @@
       </p:sp>
       <p:sp>
         <p:nvSpPr>
-          <p:cNvPr id="30" name=""/>
+          <p:cNvPr id="31" name=""/>
           <p:cNvSpPr txBox="1"/>
           <p:nvPr/>
         </p:nvSpPr>
@@ -16224,7 +16237,7 @@
       </p:sp>
       <p:sp>
         <p:nvSpPr>
-          <p:cNvPr id="31" name=""/>
+          <p:cNvPr id="32" name=""/>
           <p:cNvSpPr txBox="1"/>
           <p:nvPr/>
         </p:nvSpPr>
@@ -16259,7 +16272,7 @@
       </p:sp>
       <p:sp>
         <p:nvSpPr>
-          <p:cNvPr id="32" name=""/>
+          <p:cNvPr id="33" name=""/>
           <p:cNvSpPr txBox="1"/>
           <p:nvPr/>
         </p:nvSpPr>
@@ -16294,7 +16307,7 @@
       </p:sp>
       <p:sp>
         <p:nvSpPr>
-          <p:cNvPr id="33" name=""/>
+          <p:cNvPr id="34" name=""/>
           <p:cNvSpPr txBox="1"/>
           <p:nvPr/>
         </p:nvSpPr>
@@ -16343,7 +16356,7 @@
       </p:sp>
       <p:sp>
         <p:nvSpPr>
-          <p:cNvPr id="34" name=""/>
+          <p:cNvPr id="35" name=""/>
           <p:cNvSpPr txBox="1"/>
           <p:nvPr/>
         </p:nvSpPr>
@@ -16378,7 +16391,7 @@
       </p:sp>
       <p:sp>
         <p:nvSpPr>
-          <p:cNvPr id="35" name=""/>
+          <p:cNvPr id="36" name=""/>
           <p:cNvSpPr txBox="1"/>
           <p:nvPr/>
         </p:nvSpPr>
@@ -16427,7 +16440,7 @@
       </p:sp>
       <p:sp>
         <p:nvSpPr>
-          <p:cNvPr id="36" name=""/>
+          <p:cNvPr id="37" name=""/>
           <p:cNvSpPr txBox="1"/>
           <p:nvPr/>
         </p:nvSpPr>
@@ -16462,7 +16475,7 @@
       </p:sp>
       <p:sp>
         <p:nvSpPr>
-          <p:cNvPr id="37" name=""/>
+          <p:cNvPr id="38" name=""/>
           <p:cNvSpPr/>
           <p:nvPr/>
         </p:nvSpPr>
@@ -16485,7 +16498,7 @@
       </p:sp>
       <p:sp>
         <p:nvSpPr>
-          <p:cNvPr id="38" name=""/>
+          <p:cNvPr id="39" name=""/>
           <p:cNvSpPr txBox="1"/>
           <p:nvPr/>
         </p:nvSpPr>
@@ -16520,7 +16533,7 @@
       </p:sp>
       <p:sp>
         <p:nvSpPr>
-          <p:cNvPr id="39" name=""/>
+          <p:cNvPr id="40" name=""/>
           <p:cNvSpPr txBox="1"/>
           <p:nvPr/>
         </p:nvSpPr>
@@ -16566,7 +16579,7 @@
       </p:sp>
       <p:sp>
         <p:nvSpPr>
-          <p:cNvPr id="40" name=""/>
+          <p:cNvPr id="41" name=""/>
           <p:cNvSpPr txBox="1"/>
           <p:nvPr/>
         </p:nvSpPr>
@@ -16601,7 +16614,7 @@
       </p:sp>
       <p:sp>
         <p:nvSpPr>
-          <p:cNvPr id="41" name=""/>
+          <p:cNvPr id="42" name=""/>
           <p:cNvSpPr txBox="1"/>
           <p:nvPr/>
         </p:nvSpPr>
@@ -16636,7 +16649,7 @@
       </p:sp>
       <p:sp>
         <p:nvSpPr>
-          <p:cNvPr id="42" name=""/>
+          <p:cNvPr id="43" name=""/>
           <p:cNvSpPr txBox="1"/>
           <p:nvPr/>
         </p:nvSpPr>
@@ -16685,7 +16698,7 @@
       </p:sp>
       <p:sp>
         <p:nvSpPr>
-          <p:cNvPr id="43" name=""/>
+          <p:cNvPr id="44" name=""/>
           <p:cNvSpPr txBox="1"/>
           <p:nvPr/>
         </p:nvSpPr>
@@ -16720,7 +16733,7 @@
       </p:sp>
       <p:sp>
         <p:nvSpPr>
-          <p:cNvPr id="44" name=""/>
+          <p:cNvPr id="45" name=""/>
           <p:cNvSpPr txBox="1"/>
           <p:nvPr/>
         </p:nvSpPr>
@@ -16769,7 +16782,7 @@
       </p:sp>
       <p:sp>
         <p:nvSpPr>
-          <p:cNvPr id="45" name=""/>
+          <p:cNvPr id="46" name=""/>
           <p:cNvSpPr txBox="1"/>
           <p:nvPr/>
         </p:nvSpPr>
@@ -16804,7 +16817,7 @@
       </p:sp>
       <p:sp>
         <p:nvSpPr>
-          <p:cNvPr id="46" name=""/>
+          <p:cNvPr id="47" name=""/>
           <p:cNvSpPr txBox="1"/>
           <p:nvPr/>
         </p:nvSpPr>
@@ -16853,7 +16866,7 @@
       </p:sp>
       <p:sp>
         <p:nvSpPr>
-          <p:cNvPr id="47" name=""/>
+          <p:cNvPr id="48" name=""/>
           <p:cNvSpPr txBox="1"/>
           <p:nvPr/>
         </p:nvSpPr>
@@ -16888,7 +16901,7 @@
       </p:sp>
       <p:sp>
         <p:nvSpPr>
-          <p:cNvPr id="48" name=""/>
+          <p:cNvPr id="49" name=""/>
           <p:cNvSpPr txBox="1"/>
           <p:nvPr/>
         </p:nvSpPr>
@@ -16937,7 +16950,7 @@
       </p:sp>
       <p:sp>
         <p:nvSpPr>
-          <p:cNvPr id="49" name=""/>
+          <p:cNvPr id="50" name=""/>
           <p:cNvSpPr txBox="1"/>
           <p:nvPr/>
         </p:nvSpPr>
@@ -16972,7 +16985,7 @@
       </p:sp>
       <p:sp>
         <p:nvSpPr>
-          <p:cNvPr id="50" name=""/>
+          <p:cNvPr id="51" name=""/>
           <p:cNvSpPr txBox="1"/>
           <p:nvPr/>
         </p:nvSpPr>
@@ -17096,9 +17109,33 @@
           <a:ln/>
         </p:spPr>
       </p:sp>
-      <p:sp>
-        <p:nvSpPr>
-          <p:cNvPr id="3" name=""/>
+      <p:pic>
+        <p:nvPicPr>
+          <p:cNvPr id="3" name="Image 0" descr="手を振るキャラクター">    </p:cNvPr>
+          <p:cNvPicPr>
+            <a:picLocks noChangeAspect="1"/>
+          </p:cNvPicPr>
+          <p:nvPr/>
+        </p:nvPicPr>
+        <p:blipFill>
+          <a:blip r:embed="rId1"/>
+          <a:stretch>
+            <a:fillRect/>
+          </a:stretch>
+        </p:blipFill>
+        <p:spPr>
+          <a:xfrm>
+            <a:off x="10563225" y="5143500"/>
+            <a:ext cx="1285875" cy="1714500"/>
+          </a:xfrm>
+          <a:prstGeom prst="rect">
+            <a:avLst/>
+          </a:prstGeom>
+        </p:spPr>
+      </p:pic>
+      <p:sp>
+        <p:nvSpPr>
+          <p:cNvPr id="4" name=""/>
           <p:cNvSpPr txBox="1"/>
           <p:nvPr/>
         </p:nvSpPr>
@@ -17133,7 +17170,7 @@
       </p:sp>
       <p:sp>
         <p:nvSpPr>
-          <p:cNvPr id="4" name=""/>
+          <p:cNvPr id="5" name=""/>
           <p:cNvSpPr txBox="1"/>
           <p:nvPr/>
         </p:nvSpPr>
@@ -17190,7 +17227,7 @@
       </p:sp>
       <p:sp>
         <p:nvSpPr>
-          <p:cNvPr id="5" name=""/>
+          <p:cNvPr id="6" name=""/>
           <p:cNvSpPr/>
           <p:nvPr/>
         </p:nvSpPr>
@@ -17212,7 +17249,7 @@
       </p:sp>
       <p:sp>
         <p:nvSpPr>
-          <p:cNvPr id="6" name=""/>
+          <p:cNvPr id="7" name=""/>
           <p:cNvSpPr txBox="1"/>
           <p:nvPr/>
         </p:nvSpPr>
@@ -17247,7 +17284,7 @@
       </p:sp>
       <p:sp>
         <p:nvSpPr>
-          <p:cNvPr id="7" name=""/>
+          <p:cNvPr id="8" name=""/>
           <p:cNvSpPr txBox="1"/>
           <p:nvPr/>
         </p:nvSpPr>
@@ -17304,7 +17341,7 @@
       </p:sp>
       <p:sp>
         <p:nvSpPr>
-          <p:cNvPr id="8" name=""/>
+          <p:cNvPr id="9" name=""/>
           <p:cNvSpPr txBox="1"/>
           <p:nvPr/>
         </p:nvSpPr>
@@ -17339,7 +17376,7 @@
       </p:sp>
       <p:sp>
         <p:nvSpPr>
-          <p:cNvPr id="9" name=""/>
+          <p:cNvPr id="10" name=""/>
           <p:cNvSpPr txBox="1"/>
           <p:nvPr/>
         </p:nvSpPr>
@@ -17374,7 +17411,7 @@
       </p:sp>
       <p:sp>
         <p:nvSpPr>
-          <p:cNvPr id="10" name=""/>
+          <p:cNvPr id="11" name=""/>
           <p:cNvSpPr txBox="1"/>
           <p:nvPr/>
         </p:nvSpPr>
@@ -17423,7 +17460,7 @@
       </p:sp>
       <p:sp>
         <p:nvSpPr>
-          <p:cNvPr id="11" name=""/>
+          <p:cNvPr id="12" name=""/>
           <p:cNvSpPr txBox="1"/>
           <p:nvPr/>
         </p:nvSpPr>
@@ -17458,7 +17495,7 @@
       </p:sp>
       <p:sp>
         <p:nvSpPr>
-          <p:cNvPr id="12" name=""/>
+          <p:cNvPr id="13" name=""/>
           <p:cNvSpPr txBox="1"/>
           <p:nvPr/>
         </p:nvSpPr>
@@ -17507,7 +17544,7 @@
       </p:sp>
       <p:sp>
         <p:nvSpPr>
-          <p:cNvPr id="13" name=""/>
+          <p:cNvPr id="14" name=""/>
           <p:cNvSpPr txBox="1"/>
           <p:nvPr/>
         </p:nvSpPr>
@@ -17542,7 +17579,7 @@
       </p:sp>
       <p:sp>
         <p:nvSpPr>
-          <p:cNvPr id="14" name=""/>
+          <p:cNvPr id="15" name=""/>
           <p:cNvSpPr txBox="1"/>
           <p:nvPr/>
         </p:nvSpPr>
@@ -17591,7 +17628,7 @@
       </p:sp>
       <p:sp>
         <p:nvSpPr>
-          <p:cNvPr id="15" name=""/>
+          <p:cNvPr id="16" name=""/>
           <p:cNvSpPr txBox="1"/>
           <p:nvPr/>
         </p:nvSpPr>
@@ -17626,7 +17663,7 @@
       </p:sp>
       <p:sp>
         <p:nvSpPr>
-          <p:cNvPr id="16" name=""/>
+          <p:cNvPr id="17" name=""/>
           <p:cNvSpPr txBox="1"/>
           <p:nvPr/>
         </p:nvSpPr>
@@ -17675,7 +17712,7 @@
       </p:sp>
       <p:sp>
         <p:nvSpPr>
-          <p:cNvPr id="17" name=""/>
+          <p:cNvPr id="18" name=""/>
           <p:cNvSpPr txBox="1"/>
           <p:nvPr/>
         </p:nvSpPr>
@@ -17710,7 +17747,7 @@
       </p:sp>
       <p:sp>
         <p:nvSpPr>
-          <p:cNvPr id="18" name=""/>
+          <p:cNvPr id="19" name=""/>
           <p:cNvSpPr txBox="1"/>
           <p:nvPr/>
         </p:nvSpPr>
@@ -17745,7 +17782,7 @@
       </p:sp>
       <p:sp>
         <p:nvSpPr>
-          <p:cNvPr id="19" name=""/>
+          <p:cNvPr id="20" name=""/>
           <p:cNvSpPr txBox="1"/>
           <p:nvPr/>
         </p:nvSpPr>
@@ -17805,7 +17842,7 @@
       </p:sp>
       <p:sp>
         <p:nvSpPr>
-          <p:cNvPr id="20" name=""/>
+          <p:cNvPr id="21" name=""/>
           <p:cNvSpPr/>
           <p:nvPr/>
         </p:nvSpPr>
@@ -17828,7 +17865,7 @@
       </p:sp>
       <p:sp>
         <p:nvSpPr>
-          <p:cNvPr id="21" name=""/>
+          <p:cNvPr id="22" name=""/>
           <p:cNvSpPr txBox="1"/>
           <p:nvPr/>
         </p:nvSpPr>
@@ -17863,7 +17900,7 @@
       </p:sp>
       <p:sp>
         <p:nvSpPr>
-          <p:cNvPr id="22" name=""/>
+          <p:cNvPr id="23" name=""/>
           <p:cNvSpPr txBox="1"/>
           <p:nvPr/>
         </p:nvSpPr>
@@ -17909,7 +17946,7 @@
       </p:sp>
       <p:sp>
         <p:nvSpPr>
-          <p:cNvPr id="23" name=""/>
+          <p:cNvPr id="24" name=""/>
           <p:cNvSpPr txBox="1"/>
           <p:nvPr/>
         </p:nvSpPr>
@@ -17944,7 +17981,7 @@
       </p:sp>
       <p:sp>
         <p:nvSpPr>
-          <p:cNvPr id="24" name=""/>
+          <p:cNvPr id="25" name=""/>
           <p:cNvSpPr txBox="1"/>
           <p:nvPr/>
         </p:nvSpPr>
@@ -17979,7 +18016,7 @@
       </p:sp>
       <p:sp>
         <p:nvSpPr>
-          <p:cNvPr id="25" name=""/>
+          <p:cNvPr id="26" name=""/>
           <p:cNvSpPr txBox="1"/>
           <p:nvPr/>
         </p:nvSpPr>
@@ -18028,7 +18065,7 @@
       </p:sp>
       <p:sp>
         <p:nvSpPr>
-          <p:cNvPr id="26" name=""/>
+          <p:cNvPr id="27" name=""/>
           <p:cNvSpPr txBox="1"/>
           <p:nvPr/>
         </p:nvSpPr>
@@ -18063,7 +18100,7 @@
       </p:sp>
       <p:sp>
         <p:nvSpPr>
-          <p:cNvPr id="27" name=""/>
+          <p:cNvPr id="28" name=""/>
           <p:cNvSpPr txBox="1"/>
           <p:nvPr/>
         </p:nvSpPr>
@@ -18112,7 +18149,7 @@
       </p:sp>
       <p:sp>
         <p:nvSpPr>
-          <p:cNvPr id="28" name=""/>
+          <p:cNvPr id="29" name=""/>
           <p:cNvSpPr txBox="1"/>
           <p:nvPr/>
         </p:nvSpPr>
@@ -18147,7 +18184,7 @@
       </p:sp>
       <p:sp>
         <p:nvSpPr>
-          <p:cNvPr id="29" name=""/>
+          <p:cNvPr id="30" name=""/>
           <p:cNvSpPr txBox="1"/>
           <p:nvPr/>
         </p:nvSpPr>
@@ -18196,7 +18233,7 @@
       </p:sp>
       <p:sp>
         <p:nvSpPr>
-          <p:cNvPr id="30" name=""/>
+          <p:cNvPr id="31" name=""/>
           <p:cNvSpPr txBox="1"/>
           <p:nvPr/>
         </p:nvSpPr>
@@ -18231,7 +18268,7 @@
       </p:sp>
       <p:sp>
         <p:nvSpPr>
-          <p:cNvPr id="31" name=""/>
+          <p:cNvPr id="32" name=""/>
           <p:cNvSpPr txBox="1"/>
           <p:nvPr/>
         </p:nvSpPr>
@@ -18280,7 +18317,7 @@
       </p:sp>
       <p:sp>
         <p:nvSpPr>
-          <p:cNvPr id="32" name=""/>
+          <p:cNvPr id="33" name=""/>
           <p:cNvSpPr txBox="1"/>
           <p:nvPr/>
         </p:nvSpPr>
@@ -18315,7 +18352,7 @@
       </p:sp>
       <p:sp>
         <p:nvSpPr>
-          <p:cNvPr id="33" name=""/>
+          <p:cNvPr id="34" name=""/>
           <p:cNvSpPr txBox="1"/>
           <p:nvPr/>
         </p:nvSpPr>
@@ -18364,7 +18401,7 @@
       </p:sp>
       <p:sp>
         <p:nvSpPr>
-          <p:cNvPr id="34" name=""/>
+          <p:cNvPr id="35" name=""/>
           <p:cNvSpPr/>
           <p:nvPr/>
         </p:nvSpPr>
@@ -18387,7 +18424,7 @@
       </p:sp>
       <p:sp>
         <p:nvSpPr>
-          <p:cNvPr id="35" name=""/>
+          <p:cNvPr id="36" name=""/>
           <p:cNvSpPr txBox="1"/>
           <p:nvPr/>
         </p:nvSpPr>
@@ -18422,7 +18459,7 @@
       </p:sp>
       <p:sp>
         <p:nvSpPr>
-          <p:cNvPr id="36" name=""/>
+          <p:cNvPr id="37" name=""/>
           <p:cNvSpPr txBox="1"/>
           <p:nvPr/>
         </p:nvSpPr>
@@ -18468,7 +18505,7 @@
       </p:sp>
       <p:sp>
         <p:nvSpPr>
-          <p:cNvPr id="37" name=""/>
+          <p:cNvPr id="38" name=""/>
           <p:cNvSpPr txBox="1"/>
           <p:nvPr/>
         </p:nvSpPr>
@@ -18503,7 +18540,7 @@
       </p:sp>
       <p:sp>
         <p:nvSpPr>
-          <p:cNvPr id="38" name=""/>
+          <p:cNvPr id="39" name=""/>
           <p:cNvSpPr txBox="1"/>
           <p:nvPr/>
         </p:nvSpPr>
@@ -18538,7 +18575,7 @@
       </p:sp>
       <p:sp>
         <p:nvSpPr>
-          <p:cNvPr id="39" name=""/>
+          <p:cNvPr id="40" name=""/>
           <p:cNvSpPr txBox="1"/>
           <p:nvPr/>
         </p:nvSpPr>
@@ -18587,7 +18624,7 @@
       </p:sp>
       <p:sp>
         <p:nvSpPr>
-          <p:cNvPr id="40" name=""/>
+          <p:cNvPr id="41" name=""/>
           <p:cNvSpPr txBox="1"/>
           <p:nvPr/>
         </p:nvSpPr>
@@ -18622,7 +18659,7 @@
       </p:sp>
       <p:sp>
         <p:nvSpPr>
-          <p:cNvPr id="41" name=""/>
+          <p:cNvPr id="42" name=""/>
           <p:cNvSpPr txBox="1"/>
           <p:nvPr/>
         </p:nvSpPr>
@@ -18671,7 +18708,7 @@
       </p:sp>
       <p:sp>
         <p:nvSpPr>
-          <p:cNvPr id="42" name=""/>
+          <p:cNvPr id="43" name=""/>
           <p:cNvSpPr txBox="1"/>
           <p:nvPr/>
         </p:nvSpPr>
@@ -18706,7 +18743,7 @@
       </p:sp>
       <p:sp>
         <p:nvSpPr>
-          <p:cNvPr id="43" name=""/>
+          <p:cNvPr id="44" name=""/>
           <p:cNvSpPr txBox="1"/>
           <p:nvPr/>
         </p:nvSpPr>
@@ -18755,7 +18792,7 @@
       </p:sp>
       <p:sp>
         <p:nvSpPr>
-          <p:cNvPr id="44" name=""/>
+          <p:cNvPr id="45" name=""/>
           <p:cNvSpPr txBox="1"/>
           <p:nvPr/>
         </p:nvSpPr>
@@ -18790,7 +18827,7 @@
       </p:sp>
       <p:sp>
         <p:nvSpPr>
-          <p:cNvPr id="45" name=""/>
+          <p:cNvPr id="46" name=""/>
           <p:cNvSpPr txBox="1"/>
           <p:nvPr/>
         </p:nvSpPr>
@@ -18839,7 +18876,7 @@
       </p:sp>
       <p:sp>
         <p:nvSpPr>
-          <p:cNvPr id="46" name=""/>
+          <p:cNvPr id="47" name=""/>
           <p:cNvSpPr txBox="1"/>
           <p:nvPr/>
         </p:nvSpPr>
@@ -18874,7 +18911,7 @@
       </p:sp>
       <p:sp>
         <p:nvSpPr>
-          <p:cNvPr id="47" name=""/>
+          <p:cNvPr id="48" name=""/>
           <p:cNvSpPr txBox="1"/>
           <p:nvPr/>
         </p:nvSpPr>

</xml_diff>